<commit_message>
developing stage - trying batch processing in python
</commit_message>
<xml_diff>
--- a/image-analysis/synapse-counting/project-overview.pptx
+++ b/image-analysis/synapse-counting/project-overview.pptx
@@ -263,7 +263,7 @@
           <a:p>
             <a:fld id="{B741DFA4-C744-40DA-B848-2124ADC83FCF}" type="datetimeFigureOut">
               <a:rPr lang="nl-BE" smtClean="0"/>
-              <a:t>31/07/2023</a:t>
+              <a:t>9/08/2023</a:t>
             </a:fld>
             <a:endParaRPr lang="nl-BE"/>
           </a:p>
@@ -463,7 +463,7 @@
           <a:p>
             <a:fld id="{B741DFA4-C744-40DA-B848-2124ADC83FCF}" type="datetimeFigureOut">
               <a:rPr lang="nl-BE" smtClean="0"/>
-              <a:t>31/07/2023</a:t>
+              <a:t>9/08/2023</a:t>
             </a:fld>
             <a:endParaRPr lang="nl-BE"/>
           </a:p>
@@ -673,7 +673,7 @@
           <a:p>
             <a:fld id="{B741DFA4-C744-40DA-B848-2124ADC83FCF}" type="datetimeFigureOut">
               <a:rPr lang="nl-BE" smtClean="0"/>
-              <a:t>31/07/2023</a:t>
+              <a:t>9/08/2023</a:t>
             </a:fld>
             <a:endParaRPr lang="nl-BE"/>
           </a:p>
@@ -873,7 +873,7 @@
           <a:p>
             <a:fld id="{B741DFA4-C744-40DA-B848-2124ADC83FCF}" type="datetimeFigureOut">
               <a:rPr lang="nl-BE" smtClean="0"/>
-              <a:t>31/07/2023</a:t>
+              <a:t>9/08/2023</a:t>
             </a:fld>
             <a:endParaRPr lang="nl-BE"/>
           </a:p>
@@ -1149,7 +1149,7 @@
           <a:p>
             <a:fld id="{B741DFA4-C744-40DA-B848-2124ADC83FCF}" type="datetimeFigureOut">
               <a:rPr lang="nl-BE" smtClean="0"/>
-              <a:t>31/07/2023</a:t>
+              <a:t>9/08/2023</a:t>
             </a:fld>
             <a:endParaRPr lang="nl-BE"/>
           </a:p>
@@ -1417,7 +1417,7 @@
           <a:p>
             <a:fld id="{B741DFA4-C744-40DA-B848-2124ADC83FCF}" type="datetimeFigureOut">
               <a:rPr lang="nl-BE" smtClean="0"/>
-              <a:t>31/07/2023</a:t>
+              <a:t>9/08/2023</a:t>
             </a:fld>
             <a:endParaRPr lang="nl-BE"/>
           </a:p>
@@ -1832,7 +1832,7 @@
           <a:p>
             <a:fld id="{B741DFA4-C744-40DA-B848-2124ADC83FCF}" type="datetimeFigureOut">
               <a:rPr lang="nl-BE" smtClean="0"/>
-              <a:t>31/07/2023</a:t>
+              <a:t>9/08/2023</a:t>
             </a:fld>
             <a:endParaRPr lang="nl-BE"/>
           </a:p>
@@ -1974,7 +1974,7 @@
           <a:p>
             <a:fld id="{B741DFA4-C744-40DA-B848-2124ADC83FCF}" type="datetimeFigureOut">
               <a:rPr lang="nl-BE" smtClean="0"/>
-              <a:t>31/07/2023</a:t>
+              <a:t>9/08/2023</a:t>
             </a:fld>
             <a:endParaRPr lang="nl-BE"/>
           </a:p>
@@ -2087,7 +2087,7 @@
           <a:p>
             <a:fld id="{B741DFA4-C744-40DA-B848-2124ADC83FCF}" type="datetimeFigureOut">
               <a:rPr lang="nl-BE" smtClean="0"/>
-              <a:t>31/07/2023</a:t>
+              <a:t>9/08/2023</a:t>
             </a:fld>
             <a:endParaRPr lang="nl-BE"/>
           </a:p>
@@ -2400,7 +2400,7 @@
           <a:p>
             <a:fld id="{B741DFA4-C744-40DA-B848-2124ADC83FCF}" type="datetimeFigureOut">
               <a:rPr lang="nl-BE" smtClean="0"/>
-              <a:t>31/07/2023</a:t>
+              <a:t>9/08/2023</a:t>
             </a:fld>
             <a:endParaRPr lang="nl-BE"/>
           </a:p>
@@ -2689,7 +2689,7 @@
           <a:p>
             <a:fld id="{B741DFA4-C744-40DA-B848-2124ADC83FCF}" type="datetimeFigureOut">
               <a:rPr lang="nl-BE" smtClean="0"/>
-              <a:t>31/07/2023</a:t>
+              <a:t>9/08/2023</a:t>
             </a:fld>
             <a:endParaRPr lang="nl-BE"/>
           </a:p>
@@ -2932,7 +2932,7 @@
           <a:p>
             <a:fld id="{B741DFA4-C744-40DA-B848-2124ADC83FCF}" type="datetimeFigureOut">
               <a:rPr lang="nl-BE" smtClean="0"/>
-              <a:t>31/07/2023</a:t>
+              <a:t>9/08/2023</a:t>
             </a:fld>
             <a:endParaRPr lang="nl-BE"/>
           </a:p>

</xml_diff>

<commit_message>
make the 2nd script for the test-pipeline that calculates the mean thresholds
</commit_message>
<xml_diff>
--- a/image-analysis/synapse-counting/project-overview.pptx
+++ b/image-analysis/synapse-counting/project-overview.pptx
@@ -8,6 +8,7 @@
     <p:sldId id="256" r:id="rId2"/>
     <p:sldId id="257" r:id="rId3"/>
     <p:sldId id="258" r:id="rId4"/>
+    <p:sldId id="259" r:id="rId5"/>
   </p:sldIdLst>
   <p:sldSz cx="12192000" cy="6858000"/>
   <p:notesSz cx="6858000" cy="9144000"/>
@@ -263,7 +264,7 @@
           <a:p>
             <a:fld id="{B741DFA4-C744-40DA-B848-2124ADC83FCF}" type="datetimeFigureOut">
               <a:rPr lang="nl-BE" smtClean="0"/>
-              <a:t>9/08/2023</a:t>
+              <a:t>22/08/2023</a:t>
             </a:fld>
             <a:endParaRPr lang="nl-BE"/>
           </a:p>
@@ -463,7 +464,7 @@
           <a:p>
             <a:fld id="{B741DFA4-C744-40DA-B848-2124ADC83FCF}" type="datetimeFigureOut">
               <a:rPr lang="nl-BE" smtClean="0"/>
-              <a:t>9/08/2023</a:t>
+              <a:t>22/08/2023</a:t>
             </a:fld>
             <a:endParaRPr lang="nl-BE"/>
           </a:p>
@@ -673,7 +674,7 @@
           <a:p>
             <a:fld id="{B741DFA4-C744-40DA-B848-2124ADC83FCF}" type="datetimeFigureOut">
               <a:rPr lang="nl-BE" smtClean="0"/>
-              <a:t>9/08/2023</a:t>
+              <a:t>22/08/2023</a:t>
             </a:fld>
             <a:endParaRPr lang="nl-BE"/>
           </a:p>
@@ -873,7 +874,7 @@
           <a:p>
             <a:fld id="{B741DFA4-C744-40DA-B848-2124ADC83FCF}" type="datetimeFigureOut">
               <a:rPr lang="nl-BE" smtClean="0"/>
-              <a:t>9/08/2023</a:t>
+              <a:t>22/08/2023</a:t>
             </a:fld>
             <a:endParaRPr lang="nl-BE"/>
           </a:p>
@@ -1149,7 +1150,7 @@
           <a:p>
             <a:fld id="{B741DFA4-C744-40DA-B848-2124ADC83FCF}" type="datetimeFigureOut">
               <a:rPr lang="nl-BE" smtClean="0"/>
-              <a:t>9/08/2023</a:t>
+              <a:t>22/08/2023</a:t>
             </a:fld>
             <a:endParaRPr lang="nl-BE"/>
           </a:p>
@@ -1417,7 +1418,7 @@
           <a:p>
             <a:fld id="{B741DFA4-C744-40DA-B848-2124ADC83FCF}" type="datetimeFigureOut">
               <a:rPr lang="nl-BE" smtClean="0"/>
-              <a:t>9/08/2023</a:t>
+              <a:t>22/08/2023</a:t>
             </a:fld>
             <a:endParaRPr lang="nl-BE"/>
           </a:p>
@@ -1832,7 +1833,7 @@
           <a:p>
             <a:fld id="{B741DFA4-C744-40DA-B848-2124ADC83FCF}" type="datetimeFigureOut">
               <a:rPr lang="nl-BE" smtClean="0"/>
-              <a:t>9/08/2023</a:t>
+              <a:t>22/08/2023</a:t>
             </a:fld>
             <a:endParaRPr lang="nl-BE"/>
           </a:p>
@@ -1974,7 +1975,7 @@
           <a:p>
             <a:fld id="{B741DFA4-C744-40DA-B848-2124ADC83FCF}" type="datetimeFigureOut">
               <a:rPr lang="nl-BE" smtClean="0"/>
-              <a:t>9/08/2023</a:t>
+              <a:t>22/08/2023</a:t>
             </a:fld>
             <a:endParaRPr lang="nl-BE"/>
           </a:p>
@@ -2087,7 +2088,7 @@
           <a:p>
             <a:fld id="{B741DFA4-C744-40DA-B848-2124ADC83FCF}" type="datetimeFigureOut">
               <a:rPr lang="nl-BE" smtClean="0"/>
-              <a:t>9/08/2023</a:t>
+              <a:t>22/08/2023</a:t>
             </a:fld>
             <a:endParaRPr lang="nl-BE"/>
           </a:p>
@@ -2400,7 +2401,7 @@
           <a:p>
             <a:fld id="{B741DFA4-C744-40DA-B848-2124ADC83FCF}" type="datetimeFigureOut">
               <a:rPr lang="nl-BE" smtClean="0"/>
-              <a:t>9/08/2023</a:t>
+              <a:t>22/08/2023</a:t>
             </a:fld>
             <a:endParaRPr lang="nl-BE"/>
           </a:p>
@@ -2689,7 +2690,7 @@
           <a:p>
             <a:fld id="{B741DFA4-C744-40DA-B848-2124ADC83FCF}" type="datetimeFigureOut">
               <a:rPr lang="nl-BE" smtClean="0"/>
-              <a:t>9/08/2023</a:t>
+              <a:t>22/08/2023</a:t>
             </a:fld>
             <a:endParaRPr lang="nl-BE"/>
           </a:p>
@@ -2932,7 +2933,7 @@
           <a:p>
             <a:fld id="{B741DFA4-C744-40DA-B848-2124ADC83FCF}" type="datetimeFigureOut">
               <a:rPr lang="nl-BE" smtClean="0"/>
-              <a:t>9/08/2023</a:t>
+              <a:t>22/08/2023</a:t>
             </a:fld>
             <a:endParaRPr lang="nl-BE"/>
           </a:p>
@@ -9918,7 +9919,7 @@
         </p:blipFill>
         <p:spPr>
           <a:xfrm>
-            <a:off x="254993" y="34568"/>
+            <a:off x="185406" y="536129"/>
             <a:ext cx="2184695" cy="846805"/>
           </a:xfrm>
           <a:prstGeom prst="rect">
@@ -9926,10 +9927,2533 @@
           </a:prstGeom>
         </p:spPr>
       </p:pic>
+      <p:sp>
+        <p:nvSpPr>
+          <p:cNvPr id="6" name="Tekstvak 5">
+            <a:extLst>
+              <a:ext uri="{FF2B5EF4-FFF2-40B4-BE49-F238E27FC236}">
+                <a16:creationId xmlns:a16="http://schemas.microsoft.com/office/drawing/2014/main" id="{6A656332-7B48-3298-481C-C9F95B2BB2BC}"/>
+              </a:ext>
+            </a:extLst>
+          </p:cNvPr>
+          <p:cNvSpPr txBox="1"/>
+          <p:nvPr/>
+        </p:nvSpPr>
+        <p:spPr>
+          <a:xfrm>
+            <a:off x="353267" y="161104"/>
+            <a:ext cx="1758815" cy="369332"/>
+          </a:xfrm>
+          <a:prstGeom prst="rect">
+            <a:avLst/>
+          </a:prstGeom>
+          <a:noFill/>
+        </p:spPr>
+        <p:txBody>
+          <a:bodyPr wrap="none" rtlCol="0">
+            <a:spAutoFit/>
+          </a:bodyPr>
+          <a:lstStyle/>
+          <a:p>
+            <a:r>
+              <a:rPr lang="en-US" b="1" dirty="0"/>
+              <a:t>Original pipeline</a:t>
+            </a:r>
+            <a:endParaRPr lang="nl-NL" b="1" dirty="0"/>
+          </a:p>
+        </p:txBody>
+      </p:sp>
     </p:spTree>
     <p:extLst>
       <p:ext uri="{BB962C8B-B14F-4D97-AF65-F5344CB8AC3E}">
         <p14:creationId xmlns:p14="http://schemas.microsoft.com/office/powerpoint/2010/main" val="542943876"/>
+      </p:ext>
+    </p:extLst>
+  </p:cSld>
+  <p:clrMapOvr>
+    <a:masterClrMapping/>
+  </p:clrMapOvr>
+</p:sld>
+</file>
+
+<file path=ppt/slides/slide4.xml><?xml version="1.0" encoding="utf-8"?>
+<p:sld xmlns:a="http://schemas.openxmlformats.org/drawingml/2006/main" xmlns:r="http://schemas.openxmlformats.org/officeDocument/2006/relationships" xmlns:p="http://schemas.openxmlformats.org/presentationml/2006/main">
+  <p:cSld>
+    <p:spTree>
+      <p:nvGrpSpPr>
+        <p:cNvPr id="1" name=""/>
+        <p:cNvGrpSpPr/>
+        <p:nvPr/>
+      </p:nvGrpSpPr>
+      <p:grpSpPr>
+        <a:xfrm>
+          <a:off x="0" y="0"/>
+          <a:ext cx="0" cy="0"/>
+          <a:chOff x="0" y="0"/>
+          <a:chExt cx="0" cy="0"/>
+        </a:xfrm>
+      </p:grpSpPr>
+      <p:sp>
+        <p:nvSpPr>
+          <p:cNvPr id="2" name="Rectangle: Rounded Corners 1">
+            <a:extLst>
+              <a:ext uri="{FF2B5EF4-FFF2-40B4-BE49-F238E27FC236}">
+                <a16:creationId xmlns:a16="http://schemas.microsoft.com/office/drawing/2014/main" id="{FB8CF31A-0765-460D-BA29-62ACD4BC8A93}"/>
+              </a:ext>
+            </a:extLst>
+          </p:cNvPr>
+          <p:cNvSpPr/>
+          <p:nvPr/>
+        </p:nvSpPr>
+        <p:spPr>
+          <a:xfrm>
+            <a:off x="2572787" y="390525"/>
+            <a:ext cx="7591792" cy="3381375"/>
+          </a:xfrm>
+          <a:prstGeom prst="roundRect">
+            <a:avLst/>
+          </a:prstGeom>
+          <a:solidFill>
+            <a:schemeClr val="bg2">
+              <a:lumMod val="25000"/>
+            </a:schemeClr>
+          </a:solidFill>
+          <a:ln>
+            <a:noFill/>
+          </a:ln>
+        </p:spPr>
+        <p:style>
+          <a:lnRef idx="2">
+            <a:schemeClr val="accent3">
+              <a:shade val="50000"/>
+            </a:schemeClr>
+          </a:lnRef>
+          <a:fillRef idx="1">
+            <a:schemeClr val="accent3"/>
+          </a:fillRef>
+          <a:effectRef idx="0">
+            <a:schemeClr val="accent3"/>
+          </a:effectRef>
+          <a:fontRef idx="minor">
+            <a:schemeClr val="lt1"/>
+          </a:fontRef>
+        </p:style>
+        <p:txBody>
+          <a:bodyPr rtlCol="0" anchor="ctr"/>
+          <a:lstStyle/>
+          <a:p>
+            <a:pPr algn="ctr"/>
+            <a:endParaRPr lang="nl-BE"/>
+          </a:p>
+        </p:txBody>
+      </p:sp>
+      <p:sp>
+        <p:nvSpPr>
+          <p:cNvPr id="3" name="Rectangle: Rounded Corners 2">
+            <a:extLst>
+              <a:ext uri="{FF2B5EF4-FFF2-40B4-BE49-F238E27FC236}">
+                <a16:creationId xmlns:a16="http://schemas.microsoft.com/office/drawing/2014/main" id="{A4A3D3B3-BD36-4F3A-83E0-E695E27A330E}"/>
+              </a:ext>
+            </a:extLst>
+          </p:cNvPr>
+          <p:cNvSpPr/>
+          <p:nvPr/>
+        </p:nvSpPr>
+        <p:spPr>
+          <a:xfrm>
+            <a:off x="74429" y="1835150"/>
+            <a:ext cx="2406650" cy="260350"/>
+          </a:xfrm>
+          <a:prstGeom prst="roundRect">
+            <a:avLst/>
+          </a:prstGeom>
+          <a:noFill/>
+          <a:ln>
+            <a:solidFill>
+              <a:schemeClr val="tx1"/>
+            </a:solidFill>
+          </a:ln>
+        </p:spPr>
+        <p:style>
+          <a:lnRef idx="2">
+            <a:schemeClr val="accent1">
+              <a:shade val="50000"/>
+            </a:schemeClr>
+          </a:lnRef>
+          <a:fillRef idx="1">
+            <a:schemeClr val="accent1"/>
+          </a:fillRef>
+          <a:effectRef idx="0">
+            <a:schemeClr val="accent1"/>
+          </a:effectRef>
+          <a:fontRef idx="minor">
+            <a:schemeClr val="lt1"/>
+          </a:fontRef>
+        </p:style>
+        <p:txBody>
+          <a:bodyPr rtlCol="0" anchor="ctr"/>
+          <a:lstStyle/>
+          <a:p>
+            <a:pPr algn="ctr"/>
+            <a:endParaRPr lang="nl-BE"/>
+          </a:p>
+        </p:txBody>
+      </p:sp>
+      <p:sp>
+        <p:nvSpPr>
+          <p:cNvPr id="4" name="TextBox 3">
+            <a:extLst>
+              <a:ext uri="{FF2B5EF4-FFF2-40B4-BE49-F238E27FC236}">
+                <a16:creationId xmlns:a16="http://schemas.microsoft.com/office/drawing/2014/main" id="{902BA4D3-7B28-4FBD-8F5A-CEDAC4B9D732}"/>
+              </a:ext>
+            </a:extLst>
+          </p:cNvPr>
+          <p:cNvSpPr txBox="1"/>
+          <p:nvPr/>
+        </p:nvSpPr>
+        <p:spPr>
+          <a:xfrm>
+            <a:off x="0" y="1835150"/>
+            <a:ext cx="2555508" cy="261610"/>
+          </a:xfrm>
+          <a:prstGeom prst="rect">
+            <a:avLst/>
+          </a:prstGeom>
+          <a:noFill/>
+        </p:spPr>
+        <p:txBody>
+          <a:bodyPr wrap="none" rtlCol="0">
+            <a:spAutoFit/>
+          </a:bodyPr>
+          <a:lstStyle/>
+          <a:p>
+            <a:r>
+              <a:rPr lang="nl-BE" sz="1100" dirty="0"/>
+              <a:t>…_ProteinX_VGLUT1-PSD95_CA1-SLM.czi</a:t>
+            </a:r>
+          </a:p>
+        </p:txBody>
+      </p:sp>
+      <p:sp>
+        <p:nvSpPr>
+          <p:cNvPr id="5" name="TextBox 4">
+            <a:extLst>
+              <a:ext uri="{FF2B5EF4-FFF2-40B4-BE49-F238E27FC236}">
+                <a16:creationId xmlns:a16="http://schemas.microsoft.com/office/drawing/2014/main" id="{5F9C363F-2D25-49F0-A3A9-8B506ED165F3}"/>
+              </a:ext>
+            </a:extLst>
+          </p:cNvPr>
+          <p:cNvSpPr txBox="1"/>
+          <p:nvPr/>
+        </p:nvSpPr>
+        <p:spPr>
+          <a:xfrm>
+            <a:off x="881351" y="1422400"/>
+            <a:ext cx="681597" cy="338554"/>
+          </a:xfrm>
+          <a:prstGeom prst="rect">
+            <a:avLst/>
+          </a:prstGeom>
+          <a:noFill/>
+        </p:spPr>
+        <p:txBody>
+          <a:bodyPr wrap="none" rtlCol="0">
+            <a:spAutoFit/>
+          </a:bodyPr>
+          <a:lstStyle/>
+          <a:p>
+            <a:r>
+              <a:rPr lang="nl-BE" sz="1600" dirty="0"/>
+              <a:t>Input:</a:t>
+            </a:r>
+          </a:p>
+        </p:txBody>
+      </p:sp>
+      <p:sp>
+        <p:nvSpPr>
+          <p:cNvPr id="8" name="Rectangle: Rounded Corners 7">
+            <a:extLst>
+              <a:ext uri="{FF2B5EF4-FFF2-40B4-BE49-F238E27FC236}">
+                <a16:creationId xmlns:a16="http://schemas.microsoft.com/office/drawing/2014/main" id="{1B29D58C-03B3-41B7-9D1D-EC385456A0B4}"/>
+              </a:ext>
+            </a:extLst>
+          </p:cNvPr>
+          <p:cNvSpPr/>
+          <p:nvPr/>
+        </p:nvSpPr>
+        <p:spPr>
+          <a:xfrm>
+            <a:off x="91708" y="2169696"/>
+            <a:ext cx="2406650" cy="260350"/>
+          </a:xfrm>
+          <a:prstGeom prst="roundRect">
+            <a:avLst/>
+          </a:prstGeom>
+          <a:noFill/>
+          <a:ln>
+            <a:solidFill>
+              <a:schemeClr val="tx1"/>
+            </a:solidFill>
+          </a:ln>
+        </p:spPr>
+        <p:style>
+          <a:lnRef idx="2">
+            <a:schemeClr val="accent1">
+              <a:shade val="50000"/>
+            </a:schemeClr>
+          </a:lnRef>
+          <a:fillRef idx="1">
+            <a:schemeClr val="accent1"/>
+          </a:fillRef>
+          <a:effectRef idx="0">
+            <a:schemeClr val="accent1"/>
+          </a:effectRef>
+          <a:fontRef idx="minor">
+            <a:schemeClr val="lt1"/>
+          </a:fontRef>
+        </p:style>
+        <p:txBody>
+          <a:bodyPr rtlCol="0" anchor="ctr"/>
+          <a:lstStyle/>
+          <a:p>
+            <a:pPr algn="ctr"/>
+            <a:endParaRPr lang="nl-BE"/>
+          </a:p>
+        </p:txBody>
+      </p:sp>
+      <p:sp>
+        <p:nvSpPr>
+          <p:cNvPr id="9" name="TextBox 8">
+            <a:extLst>
+              <a:ext uri="{FF2B5EF4-FFF2-40B4-BE49-F238E27FC236}">
+                <a16:creationId xmlns:a16="http://schemas.microsoft.com/office/drawing/2014/main" id="{280DAAF7-5280-4005-81EB-E56D29C65499}"/>
+              </a:ext>
+            </a:extLst>
+          </p:cNvPr>
+          <p:cNvSpPr txBox="1"/>
+          <p:nvPr/>
+        </p:nvSpPr>
+        <p:spPr>
+          <a:xfrm>
+            <a:off x="17279" y="2169696"/>
+            <a:ext cx="2435282" cy="261610"/>
+          </a:xfrm>
+          <a:prstGeom prst="rect">
+            <a:avLst/>
+          </a:prstGeom>
+          <a:noFill/>
+        </p:spPr>
+        <p:txBody>
+          <a:bodyPr wrap="none" rtlCol="0">
+            <a:spAutoFit/>
+          </a:bodyPr>
+          <a:lstStyle/>
+          <a:p>
+            <a:r>
+              <a:rPr lang="nl-BE" sz="1100" dirty="0"/>
+              <a:t>…_ProteinX_VGLUT1-PSD95_CA3-SL.czi</a:t>
+            </a:r>
+          </a:p>
+        </p:txBody>
+      </p:sp>
+      <p:sp>
+        <p:nvSpPr>
+          <p:cNvPr id="10" name="TextBox 9">
+            <a:extLst>
+              <a:ext uri="{FF2B5EF4-FFF2-40B4-BE49-F238E27FC236}">
+                <a16:creationId xmlns:a16="http://schemas.microsoft.com/office/drawing/2014/main" id="{9AD006F3-4A16-4A7E-AD85-CC2FD78C7AC9}"/>
+              </a:ext>
+            </a:extLst>
+          </p:cNvPr>
+          <p:cNvSpPr txBox="1"/>
+          <p:nvPr/>
+        </p:nvSpPr>
+        <p:spPr>
+          <a:xfrm>
+            <a:off x="894121" y="2502982"/>
+            <a:ext cx="338554" cy="338554"/>
+          </a:xfrm>
+          <a:prstGeom prst="rect">
+            <a:avLst/>
+          </a:prstGeom>
+          <a:noFill/>
+        </p:spPr>
+        <p:txBody>
+          <a:bodyPr wrap="none" rtlCol="0">
+            <a:spAutoFit/>
+          </a:bodyPr>
+          <a:lstStyle/>
+          <a:p>
+            <a:r>
+              <a:rPr lang="nl-BE" sz="1600" dirty="0"/>
+              <a:t>…</a:t>
+            </a:r>
+          </a:p>
+        </p:txBody>
+      </p:sp>
+      <p:cxnSp>
+        <p:nvCxnSpPr>
+          <p:cNvPr id="12" name="Straight Arrow Connector 11">
+            <a:extLst>
+              <a:ext uri="{FF2B5EF4-FFF2-40B4-BE49-F238E27FC236}">
+                <a16:creationId xmlns:a16="http://schemas.microsoft.com/office/drawing/2014/main" id="{0BCC16D0-B5BF-4741-B8F5-E69FC168CEA9}"/>
+              </a:ext>
+            </a:extLst>
+          </p:cNvPr>
+          <p:cNvCxnSpPr>
+            <a:cxnSpLocks/>
+          </p:cNvCxnSpPr>
+          <p:nvPr/>
+        </p:nvCxnSpPr>
+        <p:spPr>
+          <a:xfrm>
+            <a:off x="2572787" y="1968500"/>
+            <a:ext cx="588950" cy="0"/>
+          </a:xfrm>
+          <a:prstGeom prst="straightConnector1">
+            <a:avLst/>
+          </a:prstGeom>
+          <a:ln>
+            <a:solidFill>
+              <a:schemeClr val="bg1"/>
+            </a:solidFill>
+            <a:tailEnd type="triangle"/>
+          </a:ln>
+        </p:spPr>
+        <p:style>
+          <a:lnRef idx="1">
+            <a:schemeClr val="accent1"/>
+          </a:lnRef>
+          <a:fillRef idx="0">
+            <a:schemeClr val="accent1"/>
+          </a:fillRef>
+          <a:effectRef idx="0">
+            <a:schemeClr val="accent1"/>
+          </a:effectRef>
+          <a:fontRef idx="minor">
+            <a:schemeClr val="tx1"/>
+          </a:fontRef>
+        </p:style>
+      </p:cxnSp>
+      <p:cxnSp>
+        <p:nvCxnSpPr>
+          <p:cNvPr id="13" name="Straight Arrow Connector 12">
+            <a:extLst>
+              <a:ext uri="{FF2B5EF4-FFF2-40B4-BE49-F238E27FC236}">
+                <a16:creationId xmlns:a16="http://schemas.microsoft.com/office/drawing/2014/main" id="{126AA9BD-DC42-4743-B62F-741B5EAA48FC}"/>
+              </a:ext>
+            </a:extLst>
+          </p:cNvPr>
+          <p:cNvCxnSpPr>
+            <a:cxnSpLocks/>
+          </p:cNvCxnSpPr>
+          <p:nvPr/>
+        </p:nvCxnSpPr>
+        <p:spPr>
+          <a:xfrm>
+            <a:off x="2572787" y="2305050"/>
+            <a:ext cx="588950" cy="0"/>
+          </a:xfrm>
+          <a:prstGeom prst="straightConnector1">
+            <a:avLst/>
+          </a:prstGeom>
+          <a:ln>
+            <a:solidFill>
+              <a:schemeClr val="bg1"/>
+            </a:solidFill>
+            <a:tailEnd type="triangle"/>
+          </a:ln>
+        </p:spPr>
+        <p:style>
+          <a:lnRef idx="1">
+            <a:schemeClr val="accent1"/>
+          </a:lnRef>
+          <a:fillRef idx="0">
+            <a:schemeClr val="accent1"/>
+          </a:fillRef>
+          <a:effectRef idx="0">
+            <a:schemeClr val="accent1"/>
+          </a:effectRef>
+          <a:fontRef idx="minor">
+            <a:schemeClr val="tx1"/>
+          </a:fontRef>
+        </p:style>
+      </p:cxnSp>
+      <p:sp>
+        <p:nvSpPr>
+          <p:cNvPr id="15" name="Rectangle: Rounded Corners 14">
+            <a:extLst>
+              <a:ext uri="{FF2B5EF4-FFF2-40B4-BE49-F238E27FC236}">
+                <a16:creationId xmlns:a16="http://schemas.microsoft.com/office/drawing/2014/main" id="{576C1C69-D723-4800-885F-FADD9CB51768}"/>
+              </a:ext>
+            </a:extLst>
+          </p:cNvPr>
+          <p:cNvSpPr/>
+          <p:nvPr/>
+        </p:nvSpPr>
+        <p:spPr>
+          <a:xfrm>
+            <a:off x="3161737" y="1592190"/>
+            <a:ext cx="1249810" cy="1174716"/>
+          </a:xfrm>
+          <a:prstGeom prst="roundRect">
+            <a:avLst/>
+          </a:prstGeom>
+          <a:solidFill>
+            <a:schemeClr val="accent5">
+              <a:lumMod val="75000"/>
+            </a:schemeClr>
+          </a:solidFill>
+          <a:ln>
+            <a:noFill/>
+          </a:ln>
+        </p:spPr>
+        <p:style>
+          <a:lnRef idx="2">
+            <a:schemeClr val="accent1">
+              <a:shade val="50000"/>
+            </a:schemeClr>
+          </a:lnRef>
+          <a:fillRef idx="1">
+            <a:schemeClr val="accent1"/>
+          </a:fillRef>
+          <a:effectRef idx="0">
+            <a:schemeClr val="accent1"/>
+          </a:effectRef>
+          <a:fontRef idx="minor">
+            <a:schemeClr val="lt1"/>
+          </a:fontRef>
+        </p:style>
+        <p:txBody>
+          <a:bodyPr rtlCol="0" anchor="ctr"/>
+          <a:lstStyle/>
+          <a:p>
+            <a:pPr algn="ctr"/>
+            <a:endParaRPr lang="nl-BE"/>
+          </a:p>
+        </p:txBody>
+      </p:sp>
+      <p:sp>
+        <p:nvSpPr>
+          <p:cNvPr id="16" name="TextBox 15">
+            <a:extLst>
+              <a:ext uri="{FF2B5EF4-FFF2-40B4-BE49-F238E27FC236}">
+                <a16:creationId xmlns:a16="http://schemas.microsoft.com/office/drawing/2014/main" id="{40465416-93A1-4A77-A1C6-9CD94B876692}"/>
+              </a:ext>
+            </a:extLst>
+          </p:cNvPr>
+          <p:cNvSpPr txBox="1"/>
+          <p:nvPr/>
+        </p:nvSpPr>
+        <p:spPr>
+          <a:xfrm>
+            <a:off x="3280271" y="1607361"/>
+            <a:ext cx="1010212" cy="430887"/>
+          </a:xfrm>
+          <a:prstGeom prst="rect">
+            <a:avLst/>
+          </a:prstGeom>
+          <a:noFill/>
+        </p:spPr>
+        <p:txBody>
+          <a:bodyPr wrap="none" rtlCol="0">
+            <a:spAutoFit/>
+          </a:bodyPr>
+          <a:lstStyle/>
+          <a:p>
+            <a:pPr algn="ctr"/>
+            <a:r>
+              <a:rPr lang="nl-BE" sz="1100" dirty="0" err="1">
+                <a:solidFill>
+                  <a:schemeClr val="bg1"/>
+                </a:solidFill>
+              </a:rPr>
+              <a:t>Extracting</a:t>
+            </a:r>
+            <a:r>
+              <a:rPr lang="nl-BE" sz="1100" dirty="0">
+                <a:solidFill>
+                  <a:schemeClr val="bg1"/>
+                </a:solidFill>
+              </a:rPr>
+              <a:t> </a:t>
+            </a:r>
+            <a:r>
+              <a:rPr lang="nl-BE" sz="1100" dirty="0" err="1">
+                <a:solidFill>
+                  <a:schemeClr val="bg1"/>
+                </a:solidFill>
+              </a:rPr>
+              <a:t>the</a:t>
+            </a:r>
+            <a:r>
+              <a:rPr lang="nl-BE" sz="1100" dirty="0">
+                <a:solidFill>
+                  <a:schemeClr val="bg1"/>
+                </a:solidFill>
+              </a:rPr>
+              <a:t> </a:t>
+            </a:r>
+          </a:p>
+          <a:p>
+            <a:pPr algn="ctr"/>
+            <a:r>
+              <a:rPr lang="nl-BE" sz="1100" dirty="0" err="1">
+                <a:solidFill>
+                  <a:schemeClr val="bg1"/>
+                </a:solidFill>
+              </a:rPr>
+              <a:t>thresholds</a:t>
+            </a:r>
+            <a:endParaRPr lang="nl-BE" sz="1100" dirty="0">
+              <a:solidFill>
+                <a:schemeClr val="bg1"/>
+              </a:solidFill>
+            </a:endParaRPr>
+          </a:p>
+        </p:txBody>
+      </p:sp>
+      <p:pic>
+        <p:nvPicPr>
+          <p:cNvPr id="17" name="Picture 16">
+            <a:extLst>
+              <a:ext uri="{FF2B5EF4-FFF2-40B4-BE49-F238E27FC236}">
+                <a16:creationId xmlns:a16="http://schemas.microsoft.com/office/drawing/2014/main" id="{766D81C7-ACDD-491E-B154-A9E88368900F}"/>
+              </a:ext>
+            </a:extLst>
+          </p:cNvPr>
+          <p:cNvPicPr>
+            <a:picLocks noChangeAspect="1"/>
+          </p:cNvPicPr>
+          <p:nvPr/>
+        </p:nvPicPr>
+        <p:blipFill>
+          <a:blip r:embed="rId2"/>
+          <a:stretch>
+            <a:fillRect/>
+          </a:stretch>
+        </p:blipFill>
+        <p:spPr>
+          <a:xfrm>
+            <a:off x="3522635" y="2057765"/>
+            <a:ext cx="489335" cy="500513"/>
+          </a:xfrm>
+          <a:prstGeom prst="rect">
+            <a:avLst/>
+          </a:prstGeom>
+        </p:spPr>
+      </p:pic>
+      <p:cxnSp>
+        <p:nvCxnSpPr>
+          <p:cNvPr id="19" name="Straight Arrow Connector 18">
+            <a:extLst>
+              <a:ext uri="{FF2B5EF4-FFF2-40B4-BE49-F238E27FC236}">
+                <a16:creationId xmlns:a16="http://schemas.microsoft.com/office/drawing/2014/main" id="{67173704-91D3-4375-8F42-0EDFE6B188B9}"/>
+              </a:ext>
+            </a:extLst>
+          </p:cNvPr>
+          <p:cNvCxnSpPr>
+            <a:cxnSpLocks/>
+          </p:cNvCxnSpPr>
+          <p:nvPr/>
+        </p:nvCxnSpPr>
+        <p:spPr>
+          <a:xfrm>
+            <a:off x="4397883" y="1913001"/>
+            <a:ext cx="1355490" cy="0"/>
+          </a:xfrm>
+          <a:prstGeom prst="straightConnector1">
+            <a:avLst/>
+          </a:prstGeom>
+          <a:ln>
+            <a:solidFill>
+              <a:schemeClr val="bg1"/>
+            </a:solidFill>
+            <a:tailEnd type="triangle"/>
+          </a:ln>
+        </p:spPr>
+        <p:style>
+          <a:lnRef idx="1">
+            <a:schemeClr val="accent1"/>
+          </a:lnRef>
+          <a:fillRef idx="0">
+            <a:schemeClr val="accent1"/>
+          </a:fillRef>
+          <a:effectRef idx="0">
+            <a:schemeClr val="accent1"/>
+          </a:effectRef>
+          <a:fontRef idx="minor">
+            <a:schemeClr val="tx1"/>
+          </a:fontRef>
+        </p:style>
+      </p:cxnSp>
+      <p:sp>
+        <p:nvSpPr>
+          <p:cNvPr id="24" name="Rectangle: Rounded Corners 23">
+            <a:extLst>
+              <a:ext uri="{FF2B5EF4-FFF2-40B4-BE49-F238E27FC236}">
+                <a16:creationId xmlns:a16="http://schemas.microsoft.com/office/drawing/2014/main" id="{8275AA74-C342-45F0-916E-943C194B8DDB}"/>
+              </a:ext>
+            </a:extLst>
+          </p:cNvPr>
+          <p:cNvSpPr/>
+          <p:nvPr/>
+        </p:nvSpPr>
+        <p:spPr>
+          <a:xfrm>
+            <a:off x="3522634" y="3860800"/>
+            <a:ext cx="6108545" cy="355600"/>
+          </a:xfrm>
+          <a:prstGeom prst="roundRect">
+            <a:avLst/>
+          </a:prstGeom>
+          <a:solidFill>
+            <a:schemeClr val="bg2">
+              <a:lumMod val="25000"/>
+            </a:schemeClr>
+          </a:solidFill>
+          <a:ln>
+            <a:noFill/>
+          </a:ln>
+        </p:spPr>
+        <p:style>
+          <a:lnRef idx="2">
+            <a:schemeClr val="accent1">
+              <a:shade val="50000"/>
+            </a:schemeClr>
+          </a:lnRef>
+          <a:fillRef idx="1">
+            <a:schemeClr val="accent1"/>
+          </a:fillRef>
+          <a:effectRef idx="0">
+            <a:schemeClr val="accent1"/>
+          </a:effectRef>
+          <a:fontRef idx="minor">
+            <a:schemeClr val="lt1"/>
+          </a:fontRef>
+        </p:style>
+        <p:txBody>
+          <a:bodyPr rtlCol="0" anchor="ctr"/>
+          <a:lstStyle/>
+          <a:p>
+            <a:pPr algn="ctr"/>
+            <a:endParaRPr lang="nl-BE"/>
+          </a:p>
+        </p:txBody>
+      </p:sp>
+      <p:sp>
+        <p:nvSpPr>
+          <p:cNvPr id="25" name="TextBox 24">
+            <a:extLst>
+              <a:ext uri="{FF2B5EF4-FFF2-40B4-BE49-F238E27FC236}">
+                <a16:creationId xmlns:a16="http://schemas.microsoft.com/office/drawing/2014/main" id="{911ECE9A-F768-4B6A-8593-1D75961BB1BD}"/>
+              </a:ext>
+            </a:extLst>
+          </p:cNvPr>
+          <p:cNvSpPr txBox="1"/>
+          <p:nvPr/>
+        </p:nvSpPr>
+        <p:spPr>
+          <a:xfrm>
+            <a:off x="4022900" y="3886398"/>
+            <a:ext cx="4803065" cy="307777"/>
+          </a:xfrm>
+          <a:prstGeom prst="rect">
+            <a:avLst/>
+          </a:prstGeom>
+          <a:noFill/>
+        </p:spPr>
+        <p:txBody>
+          <a:bodyPr wrap="square" rtlCol="0">
+            <a:spAutoFit/>
+          </a:bodyPr>
+          <a:lstStyle/>
+          <a:p>
+            <a:pPr algn="ctr"/>
+            <a:r>
+              <a:rPr lang="nl-BE" sz="1400" dirty="0">
+                <a:solidFill>
+                  <a:schemeClr val="bg1"/>
+                </a:solidFill>
+              </a:rPr>
+              <a:t>File export </a:t>
+            </a:r>
+            <a:r>
+              <a:rPr lang="nl-BE" sz="1400" dirty="0" err="1">
+                <a:solidFill>
+                  <a:schemeClr val="bg1"/>
+                </a:solidFill>
+              </a:rPr>
+              <a:t>for</a:t>
+            </a:r>
+            <a:r>
+              <a:rPr lang="nl-BE" sz="1400" dirty="0">
+                <a:solidFill>
+                  <a:schemeClr val="bg1"/>
+                </a:solidFill>
+              </a:rPr>
+              <a:t> </a:t>
+            </a:r>
+            <a:r>
+              <a:rPr lang="nl-BE" sz="1400" dirty="0" err="1">
+                <a:solidFill>
+                  <a:schemeClr val="bg1"/>
+                </a:solidFill>
+              </a:rPr>
+              <a:t>inspection</a:t>
+            </a:r>
+            <a:endParaRPr lang="nl-BE" sz="1400" dirty="0">
+              <a:solidFill>
+                <a:schemeClr val="bg1"/>
+              </a:solidFill>
+            </a:endParaRPr>
+          </a:p>
+        </p:txBody>
+      </p:sp>
+      <p:cxnSp>
+        <p:nvCxnSpPr>
+          <p:cNvPr id="31" name="Straight Arrow Connector 30">
+            <a:extLst>
+              <a:ext uri="{FF2B5EF4-FFF2-40B4-BE49-F238E27FC236}">
+                <a16:creationId xmlns:a16="http://schemas.microsoft.com/office/drawing/2014/main" id="{4B396A3C-1778-49AC-86D2-5D9F3702659B}"/>
+              </a:ext>
+            </a:extLst>
+          </p:cNvPr>
+          <p:cNvCxnSpPr>
+            <a:cxnSpLocks/>
+          </p:cNvCxnSpPr>
+          <p:nvPr/>
+        </p:nvCxnSpPr>
+        <p:spPr>
+          <a:xfrm>
+            <a:off x="7032007" y="2281992"/>
+            <a:ext cx="1576822" cy="0"/>
+          </a:xfrm>
+          <a:prstGeom prst="straightConnector1">
+            <a:avLst/>
+          </a:prstGeom>
+          <a:ln>
+            <a:solidFill>
+              <a:schemeClr val="bg1"/>
+            </a:solidFill>
+            <a:tailEnd type="triangle"/>
+          </a:ln>
+        </p:spPr>
+        <p:style>
+          <a:lnRef idx="1">
+            <a:schemeClr val="accent1"/>
+          </a:lnRef>
+          <a:fillRef idx="0">
+            <a:schemeClr val="accent1"/>
+          </a:fillRef>
+          <a:effectRef idx="0">
+            <a:schemeClr val="accent1"/>
+          </a:effectRef>
+          <a:fontRef idx="minor">
+            <a:schemeClr val="tx1"/>
+          </a:fontRef>
+        </p:style>
+      </p:cxnSp>
+      <p:sp>
+        <p:nvSpPr>
+          <p:cNvPr id="33" name="TextBox 32">
+            <a:extLst>
+              <a:ext uri="{FF2B5EF4-FFF2-40B4-BE49-F238E27FC236}">
+                <a16:creationId xmlns:a16="http://schemas.microsoft.com/office/drawing/2014/main" id="{A18E2243-F66D-4A47-BF27-A37FE245372E}"/>
+              </a:ext>
+            </a:extLst>
+          </p:cNvPr>
+          <p:cNvSpPr txBox="1"/>
+          <p:nvPr/>
+        </p:nvSpPr>
+        <p:spPr>
+          <a:xfrm>
+            <a:off x="3293806" y="362631"/>
+            <a:ext cx="6449962" cy="584775"/>
+          </a:xfrm>
+          <a:prstGeom prst="rect">
+            <a:avLst/>
+          </a:prstGeom>
+          <a:noFill/>
+        </p:spPr>
+        <p:txBody>
+          <a:bodyPr wrap="square" rtlCol="0">
+            <a:spAutoFit/>
+          </a:bodyPr>
+          <a:lstStyle/>
+          <a:p>
+            <a:pPr algn="ctr"/>
+            <a:r>
+              <a:rPr lang="nl-BE" sz="2000" dirty="0" err="1">
+                <a:solidFill>
+                  <a:schemeClr val="bg1"/>
+                </a:solidFill>
+              </a:rPr>
+              <a:t>Synapse</a:t>
+            </a:r>
+            <a:r>
+              <a:rPr lang="nl-BE" sz="2000" dirty="0">
+                <a:solidFill>
+                  <a:schemeClr val="bg1"/>
+                </a:solidFill>
+              </a:rPr>
+              <a:t> </a:t>
+            </a:r>
+            <a:r>
+              <a:rPr lang="nl-BE" sz="2000" dirty="0" err="1">
+                <a:solidFill>
+                  <a:schemeClr val="bg1"/>
+                </a:solidFill>
+              </a:rPr>
+              <a:t>counting</a:t>
+            </a:r>
+            <a:r>
+              <a:rPr lang="nl-BE" sz="2000" dirty="0">
+                <a:solidFill>
+                  <a:schemeClr val="bg1"/>
+                </a:solidFill>
+              </a:rPr>
+              <a:t> image analysis pipeline - </a:t>
+            </a:r>
+            <a:r>
+              <a:rPr lang="nl-BE" sz="2000" dirty="0" err="1">
+                <a:solidFill>
+                  <a:schemeClr val="bg1"/>
+                </a:solidFill>
+              </a:rPr>
+              <a:t>surrogate</a:t>
+            </a:r>
+            <a:endParaRPr lang="nl-BE" sz="2000" dirty="0">
+              <a:solidFill>
+                <a:schemeClr val="bg1"/>
+              </a:solidFill>
+            </a:endParaRPr>
+          </a:p>
+          <a:p>
+            <a:pPr algn="ctr"/>
+            <a:r>
+              <a:rPr lang="nl-BE" sz="1200" dirty="0">
+                <a:solidFill>
+                  <a:schemeClr val="bg1"/>
+                </a:solidFill>
+              </a:rPr>
+              <a:t>- For </a:t>
+            </a:r>
+            <a:r>
+              <a:rPr lang="nl-BE" sz="1200" dirty="0" err="1">
+                <a:solidFill>
+                  <a:schemeClr val="bg1"/>
+                </a:solidFill>
+              </a:rPr>
+              <a:t>each</a:t>
+            </a:r>
+            <a:r>
+              <a:rPr lang="nl-BE" sz="1200" dirty="0">
+                <a:solidFill>
+                  <a:schemeClr val="bg1"/>
+                </a:solidFill>
+              </a:rPr>
+              <a:t> </a:t>
+            </a:r>
+            <a:r>
+              <a:rPr lang="nl-BE" sz="1200" dirty="0" err="1">
+                <a:solidFill>
+                  <a:schemeClr val="bg1"/>
+                </a:solidFill>
+              </a:rPr>
+              <a:t>experimental</a:t>
+            </a:r>
+            <a:r>
+              <a:rPr lang="nl-BE" sz="1200" dirty="0">
+                <a:solidFill>
+                  <a:schemeClr val="bg1"/>
+                </a:solidFill>
+              </a:rPr>
+              <a:t> </a:t>
+            </a:r>
+            <a:r>
+              <a:rPr lang="nl-BE" sz="1200" dirty="0" err="1">
+                <a:solidFill>
+                  <a:schemeClr val="bg1"/>
+                </a:solidFill>
+              </a:rPr>
+              <a:t>replicate</a:t>
+            </a:r>
+            <a:endParaRPr lang="nl-BE" sz="1200" dirty="0">
+              <a:solidFill>
+                <a:schemeClr val="bg1"/>
+              </a:solidFill>
+            </a:endParaRPr>
+          </a:p>
+        </p:txBody>
+      </p:sp>
+      <p:cxnSp>
+        <p:nvCxnSpPr>
+          <p:cNvPr id="35" name="Straight Arrow Connector 34">
+            <a:extLst>
+              <a:ext uri="{FF2B5EF4-FFF2-40B4-BE49-F238E27FC236}">
+                <a16:creationId xmlns:a16="http://schemas.microsoft.com/office/drawing/2014/main" id="{71A1AF38-6FA0-439C-BFBE-D77FF6D95819}"/>
+              </a:ext>
+            </a:extLst>
+          </p:cNvPr>
+          <p:cNvCxnSpPr>
+            <a:cxnSpLocks/>
+          </p:cNvCxnSpPr>
+          <p:nvPr/>
+        </p:nvCxnSpPr>
+        <p:spPr>
+          <a:xfrm>
+            <a:off x="7413685" y="2502982"/>
+            <a:ext cx="0" cy="1262568"/>
+          </a:xfrm>
+          <a:prstGeom prst="straightConnector1">
+            <a:avLst/>
+          </a:prstGeom>
+          <a:ln>
+            <a:solidFill>
+              <a:schemeClr val="bg1"/>
+            </a:solidFill>
+            <a:tailEnd type="triangle"/>
+          </a:ln>
+        </p:spPr>
+        <p:style>
+          <a:lnRef idx="1">
+            <a:schemeClr val="accent1"/>
+          </a:lnRef>
+          <a:fillRef idx="0">
+            <a:schemeClr val="accent1"/>
+          </a:fillRef>
+          <a:effectRef idx="0">
+            <a:schemeClr val="accent1"/>
+          </a:effectRef>
+          <a:fontRef idx="minor">
+            <a:schemeClr val="tx1"/>
+          </a:fontRef>
+        </p:style>
+      </p:cxnSp>
+      <p:sp>
+        <p:nvSpPr>
+          <p:cNvPr id="37" name="Rectangle: Rounded Corners 36">
+            <a:extLst>
+              <a:ext uri="{FF2B5EF4-FFF2-40B4-BE49-F238E27FC236}">
+                <a16:creationId xmlns:a16="http://schemas.microsoft.com/office/drawing/2014/main" id="{72EA7501-E2D8-4B01-B254-50B8A0AD4A08}"/>
+              </a:ext>
+            </a:extLst>
+          </p:cNvPr>
+          <p:cNvSpPr/>
+          <p:nvPr/>
+        </p:nvSpPr>
+        <p:spPr>
+          <a:xfrm>
+            <a:off x="5780105" y="1607361"/>
+            <a:ext cx="1249810" cy="1174716"/>
+          </a:xfrm>
+          <a:prstGeom prst="roundRect">
+            <a:avLst/>
+          </a:prstGeom>
+          <a:solidFill>
+            <a:schemeClr val="accent5">
+              <a:lumMod val="75000"/>
+            </a:schemeClr>
+          </a:solidFill>
+          <a:ln>
+            <a:noFill/>
+          </a:ln>
+        </p:spPr>
+        <p:style>
+          <a:lnRef idx="2">
+            <a:schemeClr val="accent1">
+              <a:shade val="50000"/>
+            </a:schemeClr>
+          </a:lnRef>
+          <a:fillRef idx="1">
+            <a:schemeClr val="accent1"/>
+          </a:fillRef>
+          <a:effectRef idx="0">
+            <a:schemeClr val="accent1"/>
+          </a:effectRef>
+          <a:fontRef idx="minor">
+            <a:schemeClr val="lt1"/>
+          </a:fontRef>
+        </p:style>
+        <p:txBody>
+          <a:bodyPr rtlCol="0" anchor="ctr"/>
+          <a:lstStyle/>
+          <a:p>
+            <a:pPr algn="ctr"/>
+            <a:endParaRPr lang="nl-BE"/>
+          </a:p>
+        </p:txBody>
+      </p:sp>
+      <p:pic>
+        <p:nvPicPr>
+          <p:cNvPr id="29" name="Picture 28">
+            <a:extLst>
+              <a:ext uri="{FF2B5EF4-FFF2-40B4-BE49-F238E27FC236}">
+                <a16:creationId xmlns:a16="http://schemas.microsoft.com/office/drawing/2014/main" id="{72C232FD-DE71-4569-840B-E3C76FE78D94}"/>
+              </a:ext>
+            </a:extLst>
+          </p:cNvPr>
+          <p:cNvPicPr>
+            <a:picLocks noChangeAspect="1"/>
+          </p:cNvPicPr>
+          <p:nvPr/>
+        </p:nvPicPr>
+        <p:blipFill>
+          <a:blip r:embed="rId2"/>
+          <a:stretch>
+            <a:fillRect/>
+          </a:stretch>
+        </p:blipFill>
+        <p:spPr>
+          <a:xfrm>
+            <a:off x="6183760" y="2041987"/>
+            <a:ext cx="489335" cy="500513"/>
+          </a:xfrm>
+          <a:prstGeom prst="rect">
+            <a:avLst/>
+          </a:prstGeom>
+        </p:spPr>
+      </p:pic>
+      <p:sp>
+        <p:nvSpPr>
+          <p:cNvPr id="28" name="TextBox 27">
+            <a:extLst>
+              <a:ext uri="{FF2B5EF4-FFF2-40B4-BE49-F238E27FC236}">
+                <a16:creationId xmlns:a16="http://schemas.microsoft.com/office/drawing/2014/main" id="{38F73343-7994-4A47-8816-C30601355AB6}"/>
+              </a:ext>
+            </a:extLst>
+          </p:cNvPr>
+          <p:cNvSpPr txBox="1"/>
+          <p:nvPr/>
+        </p:nvSpPr>
+        <p:spPr>
+          <a:xfrm>
+            <a:off x="5876046" y="1607360"/>
+            <a:ext cx="1096774" cy="430887"/>
+          </a:xfrm>
+          <a:prstGeom prst="rect">
+            <a:avLst/>
+          </a:prstGeom>
+          <a:noFill/>
+        </p:spPr>
+        <p:txBody>
+          <a:bodyPr wrap="none" rtlCol="0">
+            <a:spAutoFit/>
+          </a:bodyPr>
+          <a:lstStyle/>
+          <a:p>
+            <a:pPr algn="ctr"/>
+            <a:r>
+              <a:rPr lang="nl-BE" sz="1100" dirty="0" err="1">
+                <a:solidFill>
+                  <a:schemeClr val="bg1"/>
+                </a:solidFill>
+              </a:rPr>
+              <a:t>Calculate</a:t>
+            </a:r>
+            <a:r>
+              <a:rPr lang="nl-BE" sz="1100" dirty="0">
+                <a:solidFill>
+                  <a:schemeClr val="bg1"/>
+                </a:solidFill>
+              </a:rPr>
+              <a:t> </a:t>
+            </a:r>
+            <a:r>
+              <a:rPr lang="nl-BE" sz="1100" dirty="0" err="1">
+                <a:solidFill>
+                  <a:schemeClr val="bg1"/>
+                </a:solidFill>
+              </a:rPr>
+              <a:t>mean</a:t>
+            </a:r>
+            <a:r>
+              <a:rPr lang="nl-BE" sz="1100" dirty="0">
+                <a:solidFill>
+                  <a:schemeClr val="bg1"/>
+                </a:solidFill>
+              </a:rPr>
+              <a:t> </a:t>
+            </a:r>
+          </a:p>
+          <a:p>
+            <a:pPr algn="ctr"/>
+            <a:r>
+              <a:rPr lang="nl-BE" sz="1100" dirty="0" err="1">
+                <a:solidFill>
+                  <a:schemeClr val="bg1"/>
+                </a:solidFill>
+              </a:rPr>
+              <a:t>thresholds</a:t>
+            </a:r>
+            <a:endParaRPr lang="nl-BE" sz="1100" dirty="0">
+              <a:solidFill>
+                <a:schemeClr val="bg1"/>
+              </a:solidFill>
+            </a:endParaRPr>
+          </a:p>
+        </p:txBody>
+      </p:sp>
+      <p:sp>
+        <p:nvSpPr>
+          <p:cNvPr id="38" name="TextBox 37">
+            <a:extLst>
+              <a:ext uri="{FF2B5EF4-FFF2-40B4-BE49-F238E27FC236}">
+                <a16:creationId xmlns:a16="http://schemas.microsoft.com/office/drawing/2014/main" id="{3C9C6FAB-3F3F-43BF-BF2C-40CB56406D71}"/>
+              </a:ext>
+            </a:extLst>
+          </p:cNvPr>
+          <p:cNvSpPr txBox="1"/>
+          <p:nvPr/>
+        </p:nvSpPr>
+        <p:spPr>
+          <a:xfrm>
+            <a:off x="4413951" y="1113851"/>
+            <a:ext cx="1000595" cy="430887"/>
+          </a:xfrm>
+          <a:prstGeom prst="rect">
+            <a:avLst/>
+          </a:prstGeom>
+          <a:noFill/>
+        </p:spPr>
+        <p:txBody>
+          <a:bodyPr wrap="none" rtlCol="0">
+            <a:spAutoFit/>
+          </a:bodyPr>
+          <a:lstStyle/>
+          <a:p>
+            <a:pPr algn="ctr"/>
+            <a:r>
+              <a:rPr lang="nl-BE" sz="1100" dirty="0">
+                <a:solidFill>
+                  <a:schemeClr val="bg1"/>
+                </a:solidFill>
+              </a:rPr>
+              <a:t>thresholds.csv</a:t>
+            </a:r>
+          </a:p>
+          <a:p>
+            <a:pPr algn="ctr"/>
+            <a:r>
+              <a:rPr lang="nl-BE" sz="1100" dirty="0">
+                <a:solidFill>
+                  <a:schemeClr val="bg1"/>
+                </a:solidFill>
+              </a:rPr>
+              <a:t>spots.tiff</a:t>
+            </a:r>
+          </a:p>
+        </p:txBody>
+      </p:sp>
+      <p:sp>
+        <p:nvSpPr>
+          <p:cNvPr id="39" name="TextBox 38">
+            <a:extLst>
+              <a:ext uri="{FF2B5EF4-FFF2-40B4-BE49-F238E27FC236}">
+                <a16:creationId xmlns:a16="http://schemas.microsoft.com/office/drawing/2014/main" id="{4009B826-89C7-4487-8F7A-E2AB68A7EAB3}"/>
+              </a:ext>
+            </a:extLst>
+          </p:cNvPr>
+          <p:cNvSpPr txBox="1"/>
+          <p:nvPr/>
+        </p:nvSpPr>
+        <p:spPr>
+          <a:xfrm>
+            <a:off x="7005406" y="1368182"/>
+            <a:ext cx="1367683" cy="261610"/>
+          </a:xfrm>
+          <a:prstGeom prst="rect">
+            <a:avLst/>
+          </a:prstGeom>
+          <a:noFill/>
+        </p:spPr>
+        <p:txBody>
+          <a:bodyPr wrap="none" rtlCol="0">
+            <a:spAutoFit/>
+          </a:bodyPr>
+          <a:lstStyle/>
+          <a:p>
+            <a:pPr algn="ctr"/>
+            <a:r>
+              <a:rPr lang="nl-BE" sz="1100" dirty="0">
+                <a:solidFill>
+                  <a:schemeClr val="bg1"/>
+                </a:solidFill>
+              </a:rPr>
+              <a:t>mean-thresholds.csv</a:t>
+            </a:r>
+          </a:p>
+        </p:txBody>
+      </p:sp>
+      <p:sp>
+        <p:nvSpPr>
+          <p:cNvPr id="41" name="Rectangle: Rounded Corners 40">
+            <a:extLst>
+              <a:ext uri="{FF2B5EF4-FFF2-40B4-BE49-F238E27FC236}">
+                <a16:creationId xmlns:a16="http://schemas.microsoft.com/office/drawing/2014/main" id="{7804CA88-28B6-41B4-9559-B8BB226DE24D}"/>
+              </a:ext>
+            </a:extLst>
+          </p:cNvPr>
+          <p:cNvSpPr/>
+          <p:nvPr/>
+        </p:nvSpPr>
+        <p:spPr>
+          <a:xfrm>
+            <a:off x="8626108" y="1603353"/>
+            <a:ext cx="1249810" cy="1174716"/>
+          </a:xfrm>
+          <a:prstGeom prst="roundRect">
+            <a:avLst/>
+          </a:prstGeom>
+          <a:solidFill>
+            <a:schemeClr val="accent5">
+              <a:lumMod val="75000"/>
+            </a:schemeClr>
+          </a:solidFill>
+          <a:ln>
+            <a:noFill/>
+          </a:ln>
+        </p:spPr>
+        <p:style>
+          <a:lnRef idx="2">
+            <a:schemeClr val="accent1">
+              <a:shade val="50000"/>
+            </a:schemeClr>
+          </a:lnRef>
+          <a:fillRef idx="1">
+            <a:schemeClr val="accent1"/>
+          </a:fillRef>
+          <a:effectRef idx="0">
+            <a:schemeClr val="accent1"/>
+          </a:effectRef>
+          <a:fontRef idx="minor">
+            <a:schemeClr val="lt1"/>
+          </a:fontRef>
+        </p:style>
+        <p:txBody>
+          <a:bodyPr rtlCol="0" anchor="ctr"/>
+          <a:lstStyle/>
+          <a:p>
+            <a:pPr algn="ctr"/>
+            <a:endParaRPr lang="nl-BE"/>
+          </a:p>
+        </p:txBody>
+      </p:sp>
+      <p:pic>
+        <p:nvPicPr>
+          <p:cNvPr id="42" name="Picture 41">
+            <a:extLst>
+              <a:ext uri="{FF2B5EF4-FFF2-40B4-BE49-F238E27FC236}">
+                <a16:creationId xmlns:a16="http://schemas.microsoft.com/office/drawing/2014/main" id="{D94F1B4E-58F8-44A2-BB92-1087D51B65D4}"/>
+              </a:ext>
+            </a:extLst>
+          </p:cNvPr>
+          <p:cNvPicPr>
+            <a:picLocks noChangeAspect="1"/>
+          </p:cNvPicPr>
+          <p:nvPr/>
+        </p:nvPicPr>
+        <p:blipFill>
+          <a:blip r:embed="rId2"/>
+          <a:stretch>
+            <a:fillRect/>
+          </a:stretch>
+        </p:blipFill>
+        <p:spPr>
+          <a:xfrm>
+            <a:off x="9029763" y="2037979"/>
+            <a:ext cx="489335" cy="500513"/>
+          </a:xfrm>
+          <a:prstGeom prst="rect">
+            <a:avLst/>
+          </a:prstGeom>
+        </p:spPr>
+      </p:pic>
+      <p:sp>
+        <p:nvSpPr>
+          <p:cNvPr id="43" name="TextBox 42">
+            <a:extLst>
+              <a:ext uri="{FF2B5EF4-FFF2-40B4-BE49-F238E27FC236}">
+                <a16:creationId xmlns:a16="http://schemas.microsoft.com/office/drawing/2014/main" id="{43AE266F-D335-4A15-9E75-D06E85CD38D6}"/>
+              </a:ext>
+            </a:extLst>
+          </p:cNvPr>
+          <p:cNvSpPr txBox="1"/>
+          <p:nvPr/>
+        </p:nvSpPr>
+        <p:spPr>
+          <a:xfrm>
+            <a:off x="8819038" y="1603352"/>
+            <a:ext cx="902811" cy="430887"/>
+          </a:xfrm>
+          <a:prstGeom prst="rect">
+            <a:avLst/>
+          </a:prstGeom>
+          <a:noFill/>
+        </p:spPr>
+        <p:txBody>
+          <a:bodyPr wrap="none" rtlCol="0">
+            <a:spAutoFit/>
+          </a:bodyPr>
+          <a:lstStyle/>
+          <a:p>
+            <a:pPr algn="ctr"/>
+            <a:r>
+              <a:rPr lang="nl-BE" sz="1100" dirty="0" err="1">
+                <a:solidFill>
+                  <a:schemeClr val="bg1"/>
+                </a:solidFill>
+              </a:rPr>
+              <a:t>Calculate</a:t>
+            </a:r>
+            <a:r>
+              <a:rPr lang="nl-BE" sz="1100" dirty="0">
+                <a:solidFill>
+                  <a:schemeClr val="bg1"/>
+                </a:solidFill>
+              </a:rPr>
+              <a:t> </a:t>
+            </a:r>
+          </a:p>
+          <a:p>
+            <a:pPr algn="ctr"/>
+            <a:r>
+              <a:rPr lang="nl-BE" sz="1100" dirty="0">
+                <a:solidFill>
+                  <a:schemeClr val="bg1"/>
+                </a:solidFill>
+              </a:rPr>
+              <a:t>overlap area</a:t>
+            </a:r>
+          </a:p>
+        </p:txBody>
+      </p:sp>
+      <p:pic>
+        <p:nvPicPr>
+          <p:cNvPr id="30" name="Picture 29">
+            <a:extLst>
+              <a:ext uri="{FF2B5EF4-FFF2-40B4-BE49-F238E27FC236}">
+                <a16:creationId xmlns:a16="http://schemas.microsoft.com/office/drawing/2014/main" id="{CA0C0B1C-6816-46B2-AB6B-3A705283B78B}"/>
+              </a:ext>
+            </a:extLst>
+          </p:cNvPr>
+          <p:cNvPicPr>
+            <a:picLocks noChangeAspect="1"/>
+          </p:cNvPicPr>
+          <p:nvPr/>
+        </p:nvPicPr>
+        <p:blipFill>
+          <a:blip r:embed="rId3"/>
+          <a:stretch>
+            <a:fillRect/>
+          </a:stretch>
+        </p:blipFill>
+        <p:spPr>
+          <a:xfrm>
+            <a:off x="7152233" y="1930881"/>
+            <a:ext cx="524004" cy="562533"/>
+          </a:xfrm>
+          <a:prstGeom prst="rect">
+            <a:avLst/>
+          </a:prstGeom>
+        </p:spPr>
+      </p:pic>
+      <p:cxnSp>
+        <p:nvCxnSpPr>
+          <p:cNvPr id="47" name="Straight Arrow Connector 46">
+            <a:extLst>
+              <a:ext uri="{FF2B5EF4-FFF2-40B4-BE49-F238E27FC236}">
+                <a16:creationId xmlns:a16="http://schemas.microsoft.com/office/drawing/2014/main" id="{0E7035EA-7A33-4615-97A4-BFFCC24CD5B6}"/>
+              </a:ext>
+            </a:extLst>
+          </p:cNvPr>
+          <p:cNvCxnSpPr>
+            <a:cxnSpLocks/>
+          </p:cNvCxnSpPr>
+          <p:nvPr/>
+        </p:nvCxnSpPr>
+        <p:spPr>
+          <a:xfrm>
+            <a:off x="9875918" y="2281992"/>
+            <a:ext cx="288661" cy="0"/>
+          </a:xfrm>
+          <a:prstGeom prst="straightConnector1">
+            <a:avLst/>
+          </a:prstGeom>
+          <a:ln>
+            <a:solidFill>
+              <a:schemeClr val="bg1"/>
+            </a:solidFill>
+            <a:tailEnd type="triangle"/>
+          </a:ln>
+        </p:spPr>
+        <p:style>
+          <a:lnRef idx="1">
+            <a:schemeClr val="accent1"/>
+          </a:lnRef>
+          <a:fillRef idx="0">
+            <a:schemeClr val="accent1"/>
+          </a:fillRef>
+          <a:effectRef idx="0">
+            <a:schemeClr val="accent1"/>
+          </a:effectRef>
+          <a:fontRef idx="minor">
+            <a:schemeClr val="tx1"/>
+          </a:fontRef>
+        </p:style>
+      </p:cxnSp>
+      <p:cxnSp>
+        <p:nvCxnSpPr>
+          <p:cNvPr id="61" name="Straight Connector 60">
+            <a:extLst>
+              <a:ext uri="{FF2B5EF4-FFF2-40B4-BE49-F238E27FC236}">
+                <a16:creationId xmlns:a16="http://schemas.microsoft.com/office/drawing/2014/main" id="{B82452F9-114E-4E03-A04E-6DA0DA92BF5F}"/>
+              </a:ext>
+            </a:extLst>
+          </p:cNvPr>
+          <p:cNvCxnSpPr/>
+          <p:nvPr/>
+        </p:nvCxnSpPr>
+        <p:spPr>
+          <a:xfrm>
+            <a:off x="2572787" y="2034239"/>
+            <a:ext cx="244842" cy="0"/>
+          </a:xfrm>
+          <a:prstGeom prst="line">
+            <a:avLst/>
+          </a:prstGeom>
+          <a:ln>
+            <a:solidFill>
+              <a:schemeClr val="bg1"/>
+            </a:solidFill>
+          </a:ln>
+        </p:spPr>
+        <p:style>
+          <a:lnRef idx="1">
+            <a:schemeClr val="accent1"/>
+          </a:lnRef>
+          <a:fillRef idx="0">
+            <a:schemeClr val="accent1"/>
+          </a:fillRef>
+          <a:effectRef idx="0">
+            <a:schemeClr val="accent1"/>
+          </a:effectRef>
+          <a:fontRef idx="minor">
+            <a:schemeClr val="tx1"/>
+          </a:fontRef>
+        </p:style>
+      </p:cxnSp>
+      <p:cxnSp>
+        <p:nvCxnSpPr>
+          <p:cNvPr id="62" name="Straight Connector 61">
+            <a:extLst>
+              <a:ext uri="{FF2B5EF4-FFF2-40B4-BE49-F238E27FC236}">
+                <a16:creationId xmlns:a16="http://schemas.microsoft.com/office/drawing/2014/main" id="{255EA008-B14B-4279-BAC7-803AC835EC5D}"/>
+              </a:ext>
+            </a:extLst>
+          </p:cNvPr>
+          <p:cNvCxnSpPr/>
+          <p:nvPr/>
+        </p:nvCxnSpPr>
+        <p:spPr>
+          <a:xfrm>
+            <a:off x="2572787" y="2370789"/>
+            <a:ext cx="244842" cy="0"/>
+          </a:xfrm>
+          <a:prstGeom prst="line">
+            <a:avLst/>
+          </a:prstGeom>
+          <a:ln>
+            <a:solidFill>
+              <a:schemeClr val="bg1"/>
+            </a:solidFill>
+          </a:ln>
+        </p:spPr>
+        <p:style>
+          <a:lnRef idx="1">
+            <a:schemeClr val="accent1"/>
+          </a:lnRef>
+          <a:fillRef idx="0">
+            <a:schemeClr val="accent1"/>
+          </a:fillRef>
+          <a:effectRef idx="0">
+            <a:schemeClr val="accent1"/>
+          </a:effectRef>
+          <a:fontRef idx="minor">
+            <a:schemeClr val="tx1"/>
+          </a:fontRef>
+        </p:style>
+      </p:cxnSp>
+      <p:cxnSp>
+        <p:nvCxnSpPr>
+          <p:cNvPr id="63" name="Straight Connector 62">
+            <a:extLst>
+              <a:ext uri="{FF2B5EF4-FFF2-40B4-BE49-F238E27FC236}">
+                <a16:creationId xmlns:a16="http://schemas.microsoft.com/office/drawing/2014/main" id="{330438E5-A923-4E09-93C1-EDCEBCD9334C}"/>
+              </a:ext>
+            </a:extLst>
+          </p:cNvPr>
+          <p:cNvCxnSpPr>
+            <a:cxnSpLocks/>
+          </p:cNvCxnSpPr>
+          <p:nvPr/>
+        </p:nvCxnSpPr>
+        <p:spPr>
+          <a:xfrm>
+            <a:off x="2811279" y="2034239"/>
+            <a:ext cx="0" cy="1172511"/>
+          </a:xfrm>
+          <a:prstGeom prst="line">
+            <a:avLst/>
+          </a:prstGeom>
+          <a:ln>
+            <a:solidFill>
+              <a:schemeClr val="bg1"/>
+            </a:solidFill>
+          </a:ln>
+        </p:spPr>
+        <p:style>
+          <a:lnRef idx="1">
+            <a:schemeClr val="accent1"/>
+          </a:lnRef>
+          <a:fillRef idx="0">
+            <a:schemeClr val="accent1"/>
+          </a:fillRef>
+          <a:effectRef idx="0">
+            <a:schemeClr val="accent1"/>
+          </a:effectRef>
+          <a:fontRef idx="minor">
+            <a:schemeClr val="tx1"/>
+          </a:fontRef>
+        </p:style>
+      </p:cxnSp>
+      <p:cxnSp>
+        <p:nvCxnSpPr>
+          <p:cNvPr id="66" name="Straight Connector 65">
+            <a:extLst>
+              <a:ext uri="{FF2B5EF4-FFF2-40B4-BE49-F238E27FC236}">
+                <a16:creationId xmlns:a16="http://schemas.microsoft.com/office/drawing/2014/main" id="{A2A373D5-F4FE-46DF-ACD4-FF8B7C897AE1}"/>
+              </a:ext>
+            </a:extLst>
+          </p:cNvPr>
+          <p:cNvCxnSpPr>
+            <a:cxnSpLocks/>
+          </p:cNvCxnSpPr>
+          <p:nvPr/>
+        </p:nvCxnSpPr>
+        <p:spPr>
+          <a:xfrm>
+            <a:off x="2804929" y="3206750"/>
+            <a:ext cx="5632450" cy="0"/>
+          </a:xfrm>
+          <a:prstGeom prst="line">
+            <a:avLst/>
+          </a:prstGeom>
+          <a:ln>
+            <a:solidFill>
+              <a:schemeClr val="bg1"/>
+            </a:solidFill>
+          </a:ln>
+        </p:spPr>
+        <p:style>
+          <a:lnRef idx="1">
+            <a:schemeClr val="accent1"/>
+          </a:lnRef>
+          <a:fillRef idx="0">
+            <a:schemeClr val="accent1"/>
+          </a:fillRef>
+          <a:effectRef idx="0">
+            <a:schemeClr val="accent1"/>
+          </a:effectRef>
+          <a:fontRef idx="minor">
+            <a:schemeClr val="tx1"/>
+          </a:fontRef>
+        </p:style>
+      </p:cxnSp>
+      <p:cxnSp>
+        <p:nvCxnSpPr>
+          <p:cNvPr id="69" name="Straight Connector 68">
+            <a:extLst>
+              <a:ext uri="{FF2B5EF4-FFF2-40B4-BE49-F238E27FC236}">
+                <a16:creationId xmlns:a16="http://schemas.microsoft.com/office/drawing/2014/main" id="{37E2A6F7-CD76-424F-B627-06644B09DFE5}"/>
+              </a:ext>
+            </a:extLst>
+          </p:cNvPr>
+          <p:cNvCxnSpPr>
+            <a:cxnSpLocks/>
+          </p:cNvCxnSpPr>
+          <p:nvPr/>
+        </p:nvCxnSpPr>
+        <p:spPr>
+          <a:xfrm>
+            <a:off x="8437379" y="2370789"/>
+            <a:ext cx="0" cy="835961"/>
+          </a:xfrm>
+          <a:prstGeom prst="line">
+            <a:avLst/>
+          </a:prstGeom>
+          <a:ln>
+            <a:solidFill>
+              <a:schemeClr val="bg1"/>
+            </a:solidFill>
+          </a:ln>
+        </p:spPr>
+        <p:style>
+          <a:lnRef idx="1">
+            <a:schemeClr val="accent1"/>
+          </a:lnRef>
+          <a:fillRef idx="0">
+            <a:schemeClr val="accent1"/>
+          </a:fillRef>
+          <a:effectRef idx="0">
+            <a:schemeClr val="accent1"/>
+          </a:effectRef>
+          <a:fontRef idx="minor">
+            <a:schemeClr val="tx1"/>
+          </a:fontRef>
+        </p:style>
+      </p:cxnSp>
+      <p:cxnSp>
+        <p:nvCxnSpPr>
+          <p:cNvPr id="72" name="Straight Arrow Connector 71">
+            <a:extLst>
+              <a:ext uri="{FF2B5EF4-FFF2-40B4-BE49-F238E27FC236}">
+                <a16:creationId xmlns:a16="http://schemas.microsoft.com/office/drawing/2014/main" id="{EA2C00EE-12C3-449B-B792-8E279A29D9BF}"/>
+              </a:ext>
+            </a:extLst>
+          </p:cNvPr>
+          <p:cNvCxnSpPr/>
+          <p:nvPr/>
+        </p:nvCxnSpPr>
+        <p:spPr>
+          <a:xfrm>
+            <a:off x="8437379" y="2370789"/>
+            <a:ext cx="171450" cy="0"/>
+          </a:xfrm>
+          <a:prstGeom prst="straightConnector1">
+            <a:avLst/>
+          </a:prstGeom>
+          <a:ln>
+            <a:solidFill>
+              <a:schemeClr val="bg1"/>
+            </a:solidFill>
+            <a:tailEnd type="triangle"/>
+          </a:ln>
+        </p:spPr>
+        <p:style>
+          <a:lnRef idx="1">
+            <a:schemeClr val="accent1"/>
+          </a:lnRef>
+          <a:fillRef idx="0">
+            <a:schemeClr val="accent1"/>
+          </a:fillRef>
+          <a:effectRef idx="0">
+            <a:schemeClr val="accent1"/>
+          </a:effectRef>
+          <a:fontRef idx="minor">
+            <a:schemeClr val="tx1"/>
+          </a:fontRef>
+        </p:style>
+      </p:cxnSp>
+      <p:pic>
+        <p:nvPicPr>
+          <p:cNvPr id="87" name="Picture 86">
+            <a:extLst>
+              <a:ext uri="{FF2B5EF4-FFF2-40B4-BE49-F238E27FC236}">
+                <a16:creationId xmlns:a16="http://schemas.microsoft.com/office/drawing/2014/main" id="{66B5FC2D-EA49-49B3-A493-4E1B718E29A7}"/>
+              </a:ext>
+            </a:extLst>
+          </p:cNvPr>
+          <p:cNvPicPr>
+            <a:picLocks noChangeAspect="1"/>
+          </p:cNvPicPr>
+          <p:nvPr/>
+        </p:nvPicPr>
+        <p:blipFill>
+          <a:blip r:embed="rId4"/>
+          <a:stretch>
+            <a:fillRect/>
+          </a:stretch>
+        </p:blipFill>
+        <p:spPr>
+          <a:xfrm>
+            <a:off x="10535477" y="2146868"/>
+            <a:ext cx="508808" cy="562533"/>
+          </a:xfrm>
+          <a:prstGeom prst="rect">
+            <a:avLst/>
+          </a:prstGeom>
+        </p:spPr>
+      </p:pic>
+      <p:pic>
+        <p:nvPicPr>
+          <p:cNvPr id="88" name="Picture 87">
+            <a:extLst>
+              <a:ext uri="{FF2B5EF4-FFF2-40B4-BE49-F238E27FC236}">
+                <a16:creationId xmlns:a16="http://schemas.microsoft.com/office/drawing/2014/main" id="{F3E9EF97-AC7F-4677-996A-5C1A4CE5C5AD}"/>
+              </a:ext>
+            </a:extLst>
+          </p:cNvPr>
+          <p:cNvPicPr>
+            <a:picLocks noChangeAspect="1"/>
+          </p:cNvPicPr>
+          <p:nvPr/>
+        </p:nvPicPr>
+        <p:blipFill>
+          <a:blip r:embed="rId3"/>
+          <a:stretch>
+            <a:fillRect/>
+          </a:stretch>
+        </p:blipFill>
+        <p:spPr>
+          <a:xfrm>
+            <a:off x="11193280" y="2143551"/>
+            <a:ext cx="524004" cy="562533"/>
+          </a:xfrm>
+          <a:prstGeom prst="rect">
+            <a:avLst/>
+          </a:prstGeom>
+        </p:spPr>
+      </p:pic>
+      <p:sp>
+        <p:nvSpPr>
+          <p:cNvPr id="89" name="TextBox 88">
+            <a:extLst>
+              <a:ext uri="{FF2B5EF4-FFF2-40B4-BE49-F238E27FC236}">
+                <a16:creationId xmlns:a16="http://schemas.microsoft.com/office/drawing/2014/main" id="{B4AE77A8-B3B8-4D70-9C46-27EA2F9EBB6F}"/>
+              </a:ext>
+            </a:extLst>
+          </p:cNvPr>
+          <p:cNvSpPr txBox="1"/>
+          <p:nvPr/>
+        </p:nvSpPr>
+        <p:spPr>
+          <a:xfrm>
+            <a:off x="10702929" y="1544738"/>
+            <a:ext cx="891591" cy="261610"/>
+          </a:xfrm>
+          <a:prstGeom prst="rect">
+            <a:avLst/>
+          </a:prstGeom>
+          <a:noFill/>
+        </p:spPr>
+        <p:txBody>
+          <a:bodyPr wrap="none" rtlCol="0">
+            <a:spAutoFit/>
+          </a:bodyPr>
+          <a:lstStyle/>
+          <a:p>
+            <a:pPr algn="ctr"/>
+            <a:r>
+              <a:rPr lang="nl-BE" sz="1100" dirty="0"/>
+              <a:t>	statistics.csv</a:t>
+            </a:r>
+          </a:p>
+        </p:txBody>
+      </p:sp>
+      <p:sp>
+        <p:nvSpPr>
+          <p:cNvPr id="90" name="TextBox 89">
+            <a:extLst>
+              <a:ext uri="{FF2B5EF4-FFF2-40B4-BE49-F238E27FC236}">
+                <a16:creationId xmlns:a16="http://schemas.microsoft.com/office/drawing/2014/main" id="{6FDB57BA-41F1-4D5D-9213-E45EF1CF560D}"/>
+              </a:ext>
+            </a:extLst>
+          </p:cNvPr>
+          <p:cNvSpPr txBox="1"/>
+          <p:nvPr/>
+        </p:nvSpPr>
+        <p:spPr>
+          <a:xfrm>
+            <a:off x="10597132" y="1771405"/>
+            <a:ext cx="1103187" cy="261610"/>
+          </a:xfrm>
+          <a:prstGeom prst="rect">
+            <a:avLst/>
+          </a:prstGeom>
+          <a:noFill/>
+        </p:spPr>
+        <p:txBody>
+          <a:bodyPr wrap="none" rtlCol="0">
+            <a:spAutoFit/>
+          </a:bodyPr>
+          <a:lstStyle/>
+          <a:p>
+            <a:pPr algn="ctr"/>
+            <a:r>
+              <a:rPr lang="nl-BE" sz="1100" dirty="0"/>
+              <a:t>	statistics_fig.csv</a:t>
+            </a:r>
+          </a:p>
+        </p:txBody>
+      </p:sp>
+      <p:sp>
+        <p:nvSpPr>
+          <p:cNvPr id="91" name="TextBox 90">
+            <a:extLst>
+              <a:ext uri="{FF2B5EF4-FFF2-40B4-BE49-F238E27FC236}">
+                <a16:creationId xmlns:a16="http://schemas.microsoft.com/office/drawing/2014/main" id="{5A5DDA7D-8719-4F85-A2ED-F724BC1430FA}"/>
+              </a:ext>
+            </a:extLst>
+          </p:cNvPr>
+          <p:cNvSpPr txBox="1"/>
+          <p:nvPr/>
+        </p:nvSpPr>
+        <p:spPr>
+          <a:xfrm>
+            <a:off x="10633671" y="2954059"/>
+            <a:ext cx="1119217" cy="261610"/>
+          </a:xfrm>
+          <a:prstGeom prst="rect">
+            <a:avLst/>
+          </a:prstGeom>
+          <a:noFill/>
+        </p:spPr>
+        <p:txBody>
+          <a:bodyPr wrap="none" rtlCol="0">
+            <a:spAutoFit/>
+          </a:bodyPr>
+          <a:lstStyle/>
+          <a:p>
+            <a:pPr algn="ctr"/>
+            <a:r>
+              <a:rPr lang="nl-BE" sz="1100" dirty="0"/>
+              <a:t>	image_spots.csv</a:t>
+            </a:r>
+          </a:p>
+        </p:txBody>
+      </p:sp>
+      <p:cxnSp>
+        <p:nvCxnSpPr>
+          <p:cNvPr id="21" name="Straight Arrow Connector 20">
+            <a:extLst>
+              <a:ext uri="{FF2B5EF4-FFF2-40B4-BE49-F238E27FC236}">
+                <a16:creationId xmlns:a16="http://schemas.microsoft.com/office/drawing/2014/main" id="{84305F6B-AF5F-445B-A55D-53BD5CF110F2}"/>
+              </a:ext>
+            </a:extLst>
+          </p:cNvPr>
+          <p:cNvCxnSpPr>
+            <a:cxnSpLocks/>
+          </p:cNvCxnSpPr>
+          <p:nvPr/>
+        </p:nvCxnSpPr>
+        <p:spPr>
+          <a:xfrm>
+            <a:off x="4867335" y="1913001"/>
+            <a:ext cx="0" cy="1852549"/>
+          </a:xfrm>
+          <a:prstGeom prst="straightConnector1">
+            <a:avLst/>
+          </a:prstGeom>
+          <a:ln>
+            <a:solidFill>
+              <a:schemeClr val="bg1"/>
+            </a:solidFill>
+            <a:tailEnd type="triangle"/>
+          </a:ln>
+        </p:spPr>
+        <p:style>
+          <a:lnRef idx="1">
+            <a:schemeClr val="accent1"/>
+          </a:lnRef>
+          <a:fillRef idx="0">
+            <a:schemeClr val="accent1"/>
+          </a:fillRef>
+          <a:effectRef idx="0">
+            <a:schemeClr val="accent1"/>
+          </a:effectRef>
+          <a:fontRef idx="minor">
+            <a:schemeClr val="tx1"/>
+          </a:fontRef>
+        </p:style>
+      </p:cxnSp>
+      <p:pic>
+        <p:nvPicPr>
+          <p:cNvPr id="18" name="Picture 17">
+            <a:extLst>
+              <a:ext uri="{FF2B5EF4-FFF2-40B4-BE49-F238E27FC236}">
+                <a16:creationId xmlns:a16="http://schemas.microsoft.com/office/drawing/2014/main" id="{960ACA0B-A6E0-4F51-89AA-469210685E4C}"/>
+              </a:ext>
+            </a:extLst>
+          </p:cNvPr>
+          <p:cNvPicPr>
+            <a:picLocks noChangeAspect="1"/>
+          </p:cNvPicPr>
+          <p:nvPr/>
+        </p:nvPicPr>
+        <p:blipFill>
+          <a:blip r:embed="rId3"/>
+          <a:stretch>
+            <a:fillRect/>
+          </a:stretch>
+        </p:blipFill>
+        <p:spPr>
+          <a:xfrm>
+            <a:off x="4612921" y="1571795"/>
+            <a:ext cx="508808" cy="546220"/>
+          </a:xfrm>
+          <a:prstGeom prst="rect">
+            <a:avLst/>
+          </a:prstGeom>
+        </p:spPr>
+      </p:pic>
+      <p:pic>
+        <p:nvPicPr>
+          <p:cNvPr id="98" name="Picture 97">
+            <a:extLst>
+              <a:ext uri="{FF2B5EF4-FFF2-40B4-BE49-F238E27FC236}">
+                <a16:creationId xmlns:a16="http://schemas.microsoft.com/office/drawing/2014/main" id="{6FB011A4-6D03-412A-91FE-D66BA2CC8C8C}"/>
+              </a:ext>
+            </a:extLst>
+          </p:cNvPr>
+          <p:cNvPicPr>
+            <a:picLocks noChangeAspect="1"/>
+          </p:cNvPicPr>
+          <p:nvPr/>
+        </p:nvPicPr>
+        <p:blipFill>
+          <a:blip r:embed="rId5"/>
+          <a:stretch>
+            <a:fillRect/>
+          </a:stretch>
+        </p:blipFill>
+        <p:spPr>
+          <a:xfrm>
+            <a:off x="10949157" y="3218986"/>
+            <a:ext cx="495101" cy="544457"/>
+          </a:xfrm>
+          <a:prstGeom prst="rect">
+            <a:avLst/>
+          </a:prstGeom>
+        </p:spPr>
+      </p:pic>
+      <p:sp>
+        <p:nvSpPr>
+          <p:cNvPr id="99" name="TextBox 98">
+            <a:extLst>
+              <a:ext uri="{FF2B5EF4-FFF2-40B4-BE49-F238E27FC236}">
+                <a16:creationId xmlns:a16="http://schemas.microsoft.com/office/drawing/2014/main" id="{1FD5B65E-31E6-4F10-92DC-F88AECB373E7}"/>
+              </a:ext>
+            </a:extLst>
+          </p:cNvPr>
+          <p:cNvSpPr txBox="1"/>
+          <p:nvPr/>
+        </p:nvSpPr>
+        <p:spPr>
+          <a:xfrm>
+            <a:off x="10730981" y="912769"/>
+            <a:ext cx="835485" cy="338554"/>
+          </a:xfrm>
+          <a:prstGeom prst="rect">
+            <a:avLst/>
+          </a:prstGeom>
+          <a:noFill/>
+        </p:spPr>
+        <p:txBody>
+          <a:bodyPr wrap="none" rtlCol="0">
+            <a:spAutoFit/>
+          </a:bodyPr>
+          <a:lstStyle/>
+          <a:p>
+            <a:r>
+              <a:rPr lang="nl-BE" sz="1600" dirty="0"/>
+              <a:t>Output:</a:t>
+            </a:r>
+          </a:p>
+        </p:txBody>
+      </p:sp>
+      <p:sp>
+        <p:nvSpPr>
+          <p:cNvPr id="100" name="TextBox 99">
+            <a:extLst>
+              <a:ext uri="{FF2B5EF4-FFF2-40B4-BE49-F238E27FC236}">
+                <a16:creationId xmlns:a16="http://schemas.microsoft.com/office/drawing/2014/main" id="{9594E085-5AB5-48E5-B43E-42D10D0C0C0A}"/>
+              </a:ext>
+            </a:extLst>
+          </p:cNvPr>
+          <p:cNvSpPr txBox="1"/>
+          <p:nvPr/>
+        </p:nvSpPr>
+        <p:spPr>
+          <a:xfrm>
+            <a:off x="1239193" y="4545147"/>
+            <a:ext cx="2239716" cy="430887"/>
+          </a:xfrm>
+          <a:prstGeom prst="rect">
+            <a:avLst/>
+          </a:prstGeom>
+          <a:noFill/>
+        </p:spPr>
+        <p:txBody>
+          <a:bodyPr wrap="none" rtlCol="0">
+            <a:spAutoFit/>
+          </a:bodyPr>
+          <a:lstStyle/>
+          <a:p>
+            <a:pPr algn="ctr"/>
+            <a:r>
+              <a:rPr lang="nl-BE" sz="1100" dirty="0"/>
+              <a:t>opt-param.csv</a:t>
+            </a:r>
+          </a:p>
+          <a:p>
+            <a:pPr algn="ctr"/>
+            <a:r>
+              <a:rPr lang="nl-BE" sz="1100" i="1" dirty="0" err="1"/>
+              <a:t>Thresholds</a:t>
+            </a:r>
+            <a:r>
+              <a:rPr lang="nl-BE" sz="1100" i="1" dirty="0"/>
+              <a:t> </a:t>
+            </a:r>
+            <a:r>
+              <a:rPr lang="nl-BE" sz="1100" i="1" dirty="0" err="1"/>
+              <a:t>for</a:t>
+            </a:r>
+            <a:r>
+              <a:rPr lang="nl-BE" sz="1100" i="1" dirty="0"/>
+              <a:t> </a:t>
+            </a:r>
+            <a:r>
+              <a:rPr lang="nl-BE" sz="1100" i="1" dirty="0" err="1"/>
+              <a:t>each</a:t>
+            </a:r>
+            <a:r>
+              <a:rPr lang="nl-BE" sz="1100" i="1" dirty="0"/>
+              <a:t> </a:t>
+            </a:r>
+            <a:r>
+              <a:rPr lang="nl-BE" sz="1100" i="1" dirty="0" err="1"/>
+              <a:t>imported</a:t>
+            </a:r>
+            <a:r>
+              <a:rPr lang="nl-BE" sz="1100" i="1" dirty="0"/>
+              <a:t> image</a:t>
+            </a:r>
+          </a:p>
+        </p:txBody>
+      </p:sp>
+      <p:cxnSp>
+        <p:nvCxnSpPr>
+          <p:cNvPr id="103" name="Straight Connector 102">
+            <a:extLst>
+              <a:ext uri="{FF2B5EF4-FFF2-40B4-BE49-F238E27FC236}">
+                <a16:creationId xmlns:a16="http://schemas.microsoft.com/office/drawing/2014/main" id="{166508AB-3D99-48DF-9CD8-8414F5BCF3A0}"/>
+              </a:ext>
+            </a:extLst>
+          </p:cNvPr>
+          <p:cNvCxnSpPr/>
+          <p:nvPr/>
+        </p:nvCxnSpPr>
+        <p:spPr>
+          <a:xfrm>
+            <a:off x="2572787" y="944519"/>
+            <a:ext cx="7591792" cy="0"/>
+          </a:xfrm>
+          <a:prstGeom prst="line">
+            <a:avLst/>
+          </a:prstGeom>
+          <a:ln>
+            <a:solidFill>
+              <a:schemeClr val="bg1"/>
+            </a:solidFill>
+          </a:ln>
+        </p:spPr>
+        <p:style>
+          <a:lnRef idx="1">
+            <a:schemeClr val="accent1"/>
+          </a:lnRef>
+          <a:fillRef idx="0">
+            <a:schemeClr val="accent1"/>
+          </a:fillRef>
+          <a:effectRef idx="0">
+            <a:schemeClr val="accent1"/>
+          </a:effectRef>
+          <a:fontRef idx="minor">
+            <a:schemeClr val="tx1"/>
+          </a:fontRef>
+        </p:style>
+      </p:cxnSp>
+      <p:sp>
+        <p:nvSpPr>
+          <p:cNvPr id="104" name="Rectangle 103">
+            <a:extLst>
+              <a:ext uri="{FF2B5EF4-FFF2-40B4-BE49-F238E27FC236}">
+                <a16:creationId xmlns:a16="http://schemas.microsoft.com/office/drawing/2014/main" id="{A9ECAC5B-07A4-4A42-BCEC-7A4098F5FDBF}"/>
+              </a:ext>
+            </a:extLst>
+          </p:cNvPr>
+          <p:cNvSpPr/>
+          <p:nvPr/>
+        </p:nvSpPr>
+        <p:spPr>
+          <a:xfrm>
+            <a:off x="5344689" y="4530842"/>
+            <a:ext cx="2034532" cy="430887"/>
+          </a:xfrm>
+          <a:prstGeom prst="rect">
+            <a:avLst/>
+          </a:prstGeom>
+        </p:spPr>
+        <p:txBody>
+          <a:bodyPr wrap="none">
+            <a:spAutoFit/>
+          </a:bodyPr>
+          <a:lstStyle/>
+          <a:p>
+            <a:pPr algn="ctr"/>
+            <a:r>
+              <a:rPr lang="nl-BE" sz="1100" dirty="0"/>
+              <a:t>mean-thresholds.csv</a:t>
+            </a:r>
+          </a:p>
+          <a:p>
+            <a:pPr algn="ctr"/>
+            <a:r>
+              <a:rPr lang="nl-BE" sz="1100" i="1" dirty="0" err="1"/>
+              <a:t>Mean</a:t>
+            </a:r>
+            <a:r>
+              <a:rPr lang="nl-BE" sz="1100" i="1" dirty="0"/>
+              <a:t> </a:t>
+            </a:r>
+            <a:r>
+              <a:rPr lang="nl-BE" sz="1100" i="1" dirty="0" err="1"/>
+              <a:t>thresholds</a:t>
+            </a:r>
+            <a:r>
+              <a:rPr lang="nl-BE" sz="1100" i="1" dirty="0"/>
+              <a:t> </a:t>
+            </a:r>
+            <a:r>
+              <a:rPr lang="nl-BE" sz="1100" i="1" dirty="0" err="1"/>
+              <a:t>for</a:t>
+            </a:r>
+            <a:r>
+              <a:rPr lang="nl-BE" sz="1100" i="1" dirty="0"/>
+              <a:t> </a:t>
+            </a:r>
+            <a:r>
+              <a:rPr lang="nl-BE" sz="1100" i="1" dirty="0" err="1"/>
+              <a:t>each</a:t>
+            </a:r>
+            <a:r>
+              <a:rPr lang="nl-BE" sz="1100" i="1" dirty="0"/>
+              <a:t> </a:t>
+            </a:r>
+            <a:r>
+              <a:rPr lang="nl-BE" sz="1100" i="1" dirty="0" err="1"/>
+              <a:t>region</a:t>
+            </a:r>
+            <a:endParaRPr lang="nl-BE" sz="1100" dirty="0"/>
+          </a:p>
+        </p:txBody>
+      </p:sp>
+      <p:sp>
+        <p:nvSpPr>
+          <p:cNvPr id="106" name="Rectangle 105">
+            <a:extLst>
+              <a:ext uri="{FF2B5EF4-FFF2-40B4-BE49-F238E27FC236}">
+                <a16:creationId xmlns:a16="http://schemas.microsoft.com/office/drawing/2014/main" id="{A429E801-4C0A-4155-A4C1-AF817FF5ABB4}"/>
+              </a:ext>
+            </a:extLst>
+          </p:cNvPr>
+          <p:cNvSpPr/>
+          <p:nvPr/>
+        </p:nvSpPr>
+        <p:spPr>
+          <a:xfrm>
+            <a:off x="8824252" y="4455321"/>
+            <a:ext cx="2392001" cy="430887"/>
+          </a:xfrm>
+          <a:prstGeom prst="rect">
+            <a:avLst/>
+          </a:prstGeom>
+        </p:spPr>
+        <p:txBody>
+          <a:bodyPr wrap="none">
+            <a:spAutoFit/>
+          </a:bodyPr>
+          <a:lstStyle/>
+          <a:p>
+            <a:pPr algn="ctr"/>
+            <a:r>
+              <a:rPr lang="nl-BE" sz="1100" dirty="0"/>
+              <a:t>statistics.csv</a:t>
+            </a:r>
+          </a:p>
+          <a:p>
+            <a:pPr algn="ctr"/>
+            <a:r>
+              <a:rPr lang="nl-BE" sz="1100" i="1" dirty="0" err="1"/>
+              <a:t>All</a:t>
+            </a:r>
+            <a:r>
+              <a:rPr lang="nl-BE" sz="1100" i="1" dirty="0"/>
+              <a:t> </a:t>
+            </a:r>
+            <a:r>
+              <a:rPr lang="nl-BE" sz="1100" i="1" dirty="0" err="1"/>
+              <a:t>statistics</a:t>
+            </a:r>
+            <a:r>
+              <a:rPr lang="nl-BE" sz="1100" i="1" dirty="0"/>
+              <a:t> </a:t>
+            </a:r>
+            <a:r>
+              <a:rPr lang="nl-BE" sz="1100" i="1" dirty="0" err="1"/>
+              <a:t>concerning</a:t>
+            </a:r>
+            <a:r>
+              <a:rPr lang="nl-BE" sz="1100" i="1" dirty="0"/>
+              <a:t> </a:t>
+            </a:r>
+            <a:r>
+              <a:rPr lang="nl-BE" sz="1100" i="1" dirty="0" err="1"/>
+              <a:t>the</a:t>
+            </a:r>
+            <a:r>
+              <a:rPr lang="nl-BE" sz="1100" i="1" dirty="0"/>
+              <a:t> </a:t>
+            </a:r>
+            <a:r>
+              <a:rPr lang="nl-BE" sz="1100" i="1" dirty="0" err="1"/>
+              <a:t>calculation</a:t>
+            </a:r>
+            <a:endParaRPr lang="nl-BE" sz="1100" dirty="0"/>
+          </a:p>
+        </p:txBody>
+      </p:sp>
+      <p:sp>
+        <p:nvSpPr>
+          <p:cNvPr id="107" name="Rectangle 106">
+            <a:extLst>
+              <a:ext uri="{FF2B5EF4-FFF2-40B4-BE49-F238E27FC236}">
+                <a16:creationId xmlns:a16="http://schemas.microsoft.com/office/drawing/2014/main" id="{B73833DE-01DC-4DBC-AC0D-167CC8010FFD}"/>
+              </a:ext>
+            </a:extLst>
+          </p:cNvPr>
+          <p:cNvSpPr/>
+          <p:nvPr/>
+        </p:nvSpPr>
+        <p:spPr>
+          <a:xfrm>
+            <a:off x="9406742" y="5156299"/>
+            <a:ext cx="1418979" cy="430887"/>
+          </a:xfrm>
+          <a:prstGeom prst="rect">
+            <a:avLst/>
+          </a:prstGeom>
+        </p:spPr>
+        <p:txBody>
+          <a:bodyPr wrap="none">
+            <a:spAutoFit/>
+          </a:bodyPr>
+          <a:lstStyle/>
+          <a:p>
+            <a:pPr algn="ctr"/>
+            <a:r>
+              <a:rPr lang="nl-BE" sz="1100" dirty="0"/>
+              <a:t>statistics.png</a:t>
+            </a:r>
+          </a:p>
+          <a:p>
+            <a:pPr algn="ctr"/>
+            <a:r>
+              <a:rPr lang="nl-BE" sz="1100" i="1" dirty="0" err="1"/>
+              <a:t>All</a:t>
+            </a:r>
+            <a:r>
+              <a:rPr lang="nl-BE" sz="1100" i="1" dirty="0"/>
+              <a:t> </a:t>
+            </a:r>
+            <a:r>
+              <a:rPr lang="nl-BE" sz="1100" i="1" dirty="0" err="1"/>
+              <a:t>statistics</a:t>
+            </a:r>
+            <a:r>
+              <a:rPr lang="nl-BE" sz="1100" i="1" dirty="0"/>
+              <a:t> in </a:t>
+            </a:r>
+            <a:r>
+              <a:rPr lang="nl-BE" sz="1100" i="1" dirty="0" err="1"/>
+              <a:t>figures</a:t>
+            </a:r>
+            <a:endParaRPr lang="nl-BE" sz="1100" dirty="0"/>
+          </a:p>
+        </p:txBody>
+      </p:sp>
+      <p:sp>
+        <p:nvSpPr>
+          <p:cNvPr id="108" name="Rectangle 107">
+            <a:extLst>
+              <a:ext uri="{FF2B5EF4-FFF2-40B4-BE49-F238E27FC236}">
+                <a16:creationId xmlns:a16="http://schemas.microsoft.com/office/drawing/2014/main" id="{008A4504-F491-4A37-8A2C-07DEA863EDD7}"/>
+              </a:ext>
+            </a:extLst>
+          </p:cNvPr>
+          <p:cNvSpPr/>
+          <p:nvPr/>
+        </p:nvSpPr>
+        <p:spPr>
+          <a:xfrm>
+            <a:off x="8181534" y="5785529"/>
+            <a:ext cx="3902030" cy="430887"/>
+          </a:xfrm>
+          <a:prstGeom prst="rect">
+            <a:avLst/>
+          </a:prstGeom>
+        </p:spPr>
+        <p:txBody>
+          <a:bodyPr wrap="none">
+            <a:spAutoFit/>
+          </a:bodyPr>
+          <a:lstStyle/>
+          <a:p>
+            <a:pPr algn="ctr"/>
+            <a:r>
+              <a:rPr lang="nl-BE" sz="1100" dirty="0" err="1"/>
+              <a:t>image_spots</a:t>
+            </a:r>
+            <a:endParaRPr lang="nl-BE" sz="1100" dirty="0"/>
+          </a:p>
+          <a:p>
+            <a:pPr algn="ctr"/>
+            <a:r>
+              <a:rPr lang="nl-BE" sz="1100" i="1" dirty="0" err="1"/>
+              <a:t>Overlapped</a:t>
+            </a:r>
+            <a:r>
+              <a:rPr lang="nl-BE" sz="1100" i="1" dirty="0"/>
+              <a:t> </a:t>
+            </a:r>
+            <a:r>
+              <a:rPr lang="nl-BE" sz="1100" i="1" dirty="0" err="1"/>
+              <a:t>regions</a:t>
+            </a:r>
+            <a:r>
+              <a:rPr lang="nl-BE" sz="1100" i="1" dirty="0"/>
+              <a:t> </a:t>
+            </a:r>
+            <a:r>
+              <a:rPr lang="nl-BE" sz="1100" i="1" dirty="0" err="1"/>
+              <a:t>for</a:t>
+            </a:r>
+            <a:r>
+              <a:rPr lang="nl-BE" sz="1100" i="1" dirty="0"/>
+              <a:t> </a:t>
+            </a:r>
+            <a:r>
+              <a:rPr lang="nl-BE" sz="1100" i="1" dirty="0" err="1"/>
+              <a:t>each</a:t>
+            </a:r>
+            <a:r>
+              <a:rPr lang="nl-BE" sz="1100" i="1" dirty="0"/>
+              <a:t> pair of images </a:t>
+            </a:r>
+            <a:r>
+              <a:rPr lang="nl-BE" sz="1100" i="1" dirty="0" err="1"/>
+              <a:t>with</a:t>
+            </a:r>
+            <a:r>
+              <a:rPr lang="nl-BE" sz="1100" i="1" dirty="0"/>
+              <a:t> </a:t>
+            </a:r>
+            <a:r>
+              <a:rPr lang="nl-BE" sz="1100" i="1" dirty="0" err="1"/>
+              <a:t>mean</a:t>
+            </a:r>
+            <a:r>
+              <a:rPr lang="nl-BE" sz="1100" i="1" dirty="0"/>
+              <a:t> </a:t>
+            </a:r>
+            <a:r>
+              <a:rPr lang="nl-BE" sz="1100" i="1" dirty="0" err="1"/>
+              <a:t>thresholds</a:t>
+            </a:r>
+            <a:endParaRPr lang="nl-BE" sz="1100" dirty="0"/>
+          </a:p>
+        </p:txBody>
+      </p:sp>
+      <p:pic>
+        <p:nvPicPr>
+          <p:cNvPr id="109" name="Picture 108">
+            <a:extLst>
+              <a:ext uri="{FF2B5EF4-FFF2-40B4-BE49-F238E27FC236}">
+                <a16:creationId xmlns:a16="http://schemas.microsoft.com/office/drawing/2014/main" id="{2056B11B-6B45-496A-9D65-E4F1BB5DB290}"/>
+              </a:ext>
+            </a:extLst>
+          </p:cNvPr>
+          <p:cNvPicPr>
+            <a:picLocks noChangeAspect="1"/>
+          </p:cNvPicPr>
+          <p:nvPr/>
+        </p:nvPicPr>
+        <p:blipFill>
+          <a:blip r:embed="rId6"/>
+          <a:stretch>
+            <a:fillRect/>
+          </a:stretch>
+        </p:blipFill>
+        <p:spPr>
+          <a:xfrm>
+            <a:off x="174352" y="536129"/>
+            <a:ext cx="2184695" cy="846805"/>
+          </a:xfrm>
+          <a:prstGeom prst="rect">
+            <a:avLst/>
+          </a:prstGeom>
+        </p:spPr>
+      </p:pic>
+      <p:sp>
+        <p:nvSpPr>
+          <p:cNvPr id="6" name="Tekstvak 5">
+            <a:extLst>
+              <a:ext uri="{FF2B5EF4-FFF2-40B4-BE49-F238E27FC236}">
+                <a16:creationId xmlns:a16="http://schemas.microsoft.com/office/drawing/2014/main" id="{150A32B2-BE43-92C3-0D90-C0C7BE9F92F4}"/>
+              </a:ext>
+            </a:extLst>
+          </p:cNvPr>
+          <p:cNvSpPr txBox="1"/>
+          <p:nvPr/>
+        </p:nvSpPr>
+        <p:spPr>
+          <a:xfrm>
+            <a:off x="337335" y="66280"/>
+            <a:ext cx="1915396" cy="646331"/>
+          </a:xfrm>
+          <a:prstGeom prst="rect">
+            <a:avLst/>
+          </a:prstGeom>
+          <a:noFill/>
+        </p:spPr>
+        <p:txBody>
+          <a:bodyPr wrap="none" rtlCol="0">
+            <a:spAutoFit/>
+          </a:bodyPr>
+          <a:lstStyle/>
+          <a:p>
+            <a:pPr algn="ctr"/>
+            <a:r>
+              <a:rPr lang="en-US" b="1" dirty="0"/>
+              <a:t>Simplified </a:t>
+            </a:r>
+          </a:p>
+          <a:p>
+            <a:pPr algn="ctr"/>
+            <a:r>
+              <a:rPr lang="en-US" b="1" dirty="0"/>
+              <a:t>surrogate pipeline</a:t>
+            </a:r>
+            <a:endParaRPr lang="nl-NL" b="1" dirty="0"/>
+          </a:p>
+        </p:txBody>
+      </p:sp>
+    </p:spTree>
+    <p:extLst>
+      <p:ext uri="{BB962C8B-B14F-4D97-AF65-F5344CB8AC3E}">
+        <p14:creationId xmlns:p14="http://schemas.microsoft.com/office/powerpoint/2010/main" val="3663025725"/>
       </p:ext>
     </p:extLst>
   </p:cSld>

</xml_diff>

<commit_message>
make the 3rd script that actually does the operation: taking the mean thresholds and applying it to the input images
</commit_message>
<xml_diff>
--- a/image-analysis/synapse-counting/project-overview.pptx
+++ b/image-analysis/synapse-counting/project-overview.pptx
@@ -264,7 +264,7 @@
           <a:p>
             <a:fld id="{B741DFA4-C744-40DA-B848-2124ADC83FCF}" type="datetimeFigureOut">
               <a:rPr lang="nl-BE" smtClean="0"/>
-              <a:t>22/08/2023</a:t>
+              <a:t>23/08/2023</a:t>
             </a:fld>
             <a:endParaRPr lang="nl-BE"/>
           </a:p>
@@ -464,7 +464,7 @@
           <a:p>
             <a:fld id="{B741DFA4-C744-40DA-B848-2124ADC83FCF}" type="datetimeFigureOut">
               <a:rPr lang="nl-BE" smtClean="0"/>
-              <a:t>22/08/2023</a:t>
+              <a:t>23/08/2023</a:t>
             </a:fld>
             <a:endParaRPr lang="nl-BE"/>
           </a:p>
@@ -674,7 +674,7 @@
           <a:p>
             <a:fld id="{B741DFA4-C744-40DA-B848-2124ADC83FCF}" type="datetimeFigureOut">
               <a:rPr lang="nl-BE" smtClean="0"/>
-              <a:t>22/08/2023</a:t>
+              <a:t>23/08/2023</a:t>
             </a:fld>
             <a:endParaRPr lang="nl-BE"/>
           </a:p>
@@ -874,7 +874,7 @@
           <a:p>
             <a:fld id="{B741DFA4-C744-40DA-B848-2124ADC83FCF}" type="datetimeFigureOut">
               <a:rPr lang="nl-BE" smtClean="0"/>
-              <a:t>22/08/2023</a:t>
+              <a:t>23/08/2023</a:t>
             </a:fld>
             <a:endParaRPr lang="nl-BE"/>
           </a:p>
@@ -1150,7 +1150,7 @@
           <a:p>
             <a:fld id="{B741DFA4-C744-40DA-B848-2124ADC83FCF}" type="datetimeFigureOut">
               <a:rPr lang="nl-BE" smtClean="0"/>
-              <a:t>22/08/2023</a:t>
+              <a:t>23/08/2023</a:t>
             </a:fld>
             <a:endParaRPr lang="nl-BE"/>
           </a:p>
@@ -1418,7 +1418,7 @@
           <a:p>
             <a:fld id="{B741DFA4-C744-40DA-B848-2124ADC83FCF}" type="datetimeFigureOut">
               <a:rPr lang="nl-BE" smtClean="0"/>
-              <a:t>22/08/2023</a:t>
+              <a:t>23/08/2023</a:t>
             </a:fld>
             <a:endParaRPr lang="nl-BE"/>
           </a:p>
@@ -1833,7 +1833,7 @@
           <a:p>
             <a:fld id="{B741DFA4-C744-40DA-B848-2124ADC83FCF}" type="datetimeFigureOut">
               <a:rPr lang="nl-BE" smtClean="0"/>
-              <a:t>22/08/2023</a:t>
+              <a:t>23/08/2023</a:t>
             </a:fld>
             <a:endParaRPr lang="nl-BE"/>
           </a:p>
@@ -1975,7 +1975,7 @@
           <a:p>
             <a:fld id="{B741DFA4-C744-40DA-B848-2124ADC83FCF}" type="datetimeFigureOut">
               <a:rPr lang="nl-BE" smtClean="0"/>
-              <a:t>22/08/2023</a:t>
+              <a:t>23/08/2023</a:t>
             </a:fld>
             <a:endParaRPr lang="nl-BE"/>
           </a:p>
@@ -2088,7 +2088,7 @@
           <a:p>
             <a:fld id="{B741DFA4-C744-40DA-B848-2124ADC83FCF}" type="datetimeFigureOut">
               <a:rPr lang="nl-BE" smtClean="0"/>
-              <a:t>22/08/2023</a:t>
+              <a:t>23/08/2023</a:t>
             </a:fld>
             <a:endParaRPr lang="nl-BE"/>
           </a:p>
@@ -2401,7 +2401,7 @@
           <a:p>
             <a:fld id="{B741DFA4-C744-40DA-B848-2124ADC83FCF}" type="datetimeFigureOut">
               <a:rPr lang="nl-BE" smtClean="0"/>
-              <a:t>22/08/2023</a:t>
+              <a:t>23/08/2023</a:t>
             </a:fld>
             <a:endParaRPr lang="nl-BE"/>
           </a:p>
@@ -2690,7 +2690,7 @@
           <a:p>
             <a:fld id="{B741DFA4-C744-40DA-B848-2124ADC83FCF}" type="datetimeFigureOut">
               <a:rPr lang="nl-BE" smtClean="0"/>
-              <a:t>22/08/2023</a:t>
+              <a:t>23/08/2023</a:t>
             </a:fld>
             <a:endParaRPr lang="nl-BE"/>
           </a:p>
@@ -2933,7 +2933,7 @@
           <a:p>
             <a:fld id="{B741DFA4-C744-40DA-B848-2124ADC83FCF}" type="datetimeFigureOut">
               <a:rPr lang="nl-BE" smtClean="0"/>
-              <a:t>22/08/2023</a:t>
+              <a:t>23/08/2023</a:t>
             </a:fld>
             <a:endParaRPr lang="nl-BE"/>
           </a:p>
@@ -5295,8 +5295,8 @@
         </p:nvSpPr>
         <p:spPr>
           <a:xfrm>
-            <a:off x="335720" y="4648378"/>
-            <a:ext cx="4711098" cy="2031325"/>
+            <a:off x="333702" y="4648378"/>
+            <a:ext cx="4715137" cy="2246769"/>
           </a:xfrm>
           <a:prstGeom prst="rect">
             <a:avLst/>
@@ -5468,6 +5468,44 @@
             <a:r>
               <a:rPr lang="nl-BE" sz="1400" dirty="0"/>
               <a:t> markers</a:t>
+            </a:r>
+          </a:p>
+          <a:p>
+            <a:r>
+              <a:rPr lang="nl-BE" sz="1400" dirty="0"/>
+              <a:t>- </a:t>
+            </a:r>
+            <a:r>
+              <a:rPr lang="nl-BE" sz="1400" dirty="0" err="1"/>
+              <a:t>with</a:t>
+            </a:r>
+            <a:r>
+              <a:rPr lang="nl-BE" sz="1400" dirty="0"/>
+              <a:t> different analyses: </a:t>
+            </a:r>
+            <a:r>
+              <a:rPr lang="nl-BE" sz="1400" dirty="0" err="1"/>
+              <a:t>coloc</a:t>
+            </a:r>
+            <a:r>
+              <a:rPr lang="nl-BE" sz="1400" dirty="0"/>
+              <a:t>, overlap, </a:t>
+            </a:r>
+            <a:r>
+              <a:rPr lang="nl-BE" sz="1400" dirty="0" err="1"/>
+              <a:t>mfi</a:t>
+            </a:r>
+            <a:r>
+              <a:rPr lang="nl-BE" sz="1400" dirty="0"/>
+              <a:t>, </a:t>
+            </a:r>
+            <a:r>
+              <a:rPr lang="nl-BE" sz="1400" dirty="0" err="1"/>
+              <a:t>pearsons</a:t>
+            </a:r>
+            <a:r>
+              <a:rPr lang="nl-BE" sz="1400" dirty="0"/>
+              <a:t>, …</a:t>
             </a:r>
           </a:p>
           <a:p>
@@ -5727,7 +5765,7 @@
         <p:spPr>
           <a:xfrm>
             <a:off x="186489" y="4602634"/>
-            <a:ext cx="5021276" cy="1815873"/>
+            <a:ext cx="5021276" cy="2246769"/>
           </a:xfrm>
           <a:prstGeom prst="rect">
             <a:avLst/>

</xml_diff>

<commit_message>
cleared the output of the ipynb scripts
</commit_message>
<xml_diff>
--- a/image-analysis/synapse-counting/project-overview.pptx
+++ b/image-analysis/synapse-counting/project-overview.pptx
@@ -9,6 +9,7 @@
     <p:sldId id="257" r:id="rId3"/>
     <p:sldId id="258" r:id="rId4"/>
     <p:sldId id="259" r:id="rId5"/>
+    <p:sldId id="260" r:id="rId6"/>
   </p:sldIdLst>
   <p:sldSz cx="12192000" cy="6858000"/>
   <p:notesSz cx="6858000" cy="9144000"/>
@@ -264,7 +265,7 @@
           <a:p>
             <a:fld id="{B741DFA4-C744-40DA-B848-2124ADC83FCF}" type="datetimeFigureOut">
               <a:rPr lang="nl-BE" smtClean="0"/>
-              <a:t>23/08/2023</a:t>
+              <a:t>25/08/2023</a:t>
             </a:fld>
             <a:endParaRPr lang="nl-BE"/>
           </a:p>
@@ -464,7 +465,7 @@
           <a:p>
             <a:fld id="{B741DFA4-C744-40DA-B848-2124ADC83FCF}" type="datetimeFigureOut">
               <a:rPr lang="nl-BE" smtClean="0"/>
-              <a:t>23/08/2023</a:t>
+              <a:t>25/08/2023</a:t>
             </a:fld>
             <a:endParaRPr lang="nl-BE"/>
           </a:p>
@@ -674,7 +675,7 @@
           <a:p>
             <a:fld id="{B741DFA4-C744-40DA-B848-2124ADC83FCF}" type="datetimeFigureOut">
               <a:rPr lang="nl-BE" smtClean="0"/>
-              <a:t>23/08/2023</a:t>
+              <a:t>25/08/2023</a:t>
             </a:fld>
             <a:endParaRPr lang="nl-BE"/>
           </a:p>
@@ -874,7 +875,7 @@
           <a:p>
             <a:fld id="{B741DFA4-C744-40DA-B848-2124ADC83FCF}" type="datetimeFigureOut">
               <a:rPr lang="nl-BE" smtClean="0"/>
-              <a:t>23/08/2023</a:t>
+              <a:t>25/08/2023</a:t>
             </a:fld>
             <a:endParaRPr lang="nl-BE"/>
           </a:p>
@@ -1150,7 +1151,7 @@
           <a:p>
             <a:fld id="{B741DFA4-C744-40DA-B848-2124ADC83FCF}" type="datetimeFigureOut">
               <a:rPr lang="nl-BE" smtClean="0"/>
-              <a:t>23/08/2023</a:t>
+              <a:t>25/08/2023</a:t>
             </a:fld>
             <a:endParaRPr lang="nl-BE"/>
           </a:p>
@@ -1418,7 +1419,7 @@
           <a:p>
             <a:fld id="{B741DFA4-C744-40DA-B848-2124ADC83FCF}" type="datetimeFigureOut">
               <a:rPr lang="nl-BE" smtClean="0"/>
-              <a:t>23/08/2023</a:t>
+              <a:t>25/08/2023</a:t>
             </a:fld>
             <a:endParaRPr lang="nl-BE"/>
           </a:p>
@@ -1833,7 +1834,7 @@
           <a:p>
             <a:fld id="{B741DFA4-C744-40DA-B848-2124ADC83FCF}" type="datetimeFigureOut">
               <a:rPr lang="nl-BE" smtClean="0"/>
-              <a:t>23/08/2023</a:t>
+              <a:t>25/08/2023</a:t>
             </a:fld>
             <a:endParaRPr lang="nl-BE"/>
           </a:p>
@@ -1975,7 +1976,7 @@
           <a:p>
             <a:fld id="{B741DFA4-C744-40DA-B848-2124ADC83FCF}" type="datetimeFigureOut">
               <a:rPr lang="nl-BE" smtClean="0"/>
-              <a:t>23/08/2023</a:t>
+              <a:t>25/08/2023</a:t>
             </a:fld>
             <a:endParaRPr lang="nl-BE"/>
           </a:p>
@@ -2088,7 +2089,7 @@
           <a:p>
             <a:fld id="{B741DFA4-C744-40DA-B848-2124ADC83FCF}" type="datetimeFigureOut">
               <a:rPr lang="nl-BE" smtClean="0"/>
-              <a:t>23/08/2023</a:t>
+              <a:t>25/08/2023</a:t>
             </a:fld>
             <a:endParaRPr lang="nl-BE"/>
           </a:p>
@@ -2401,7 +2402,7 @@
           <a:p>
             <a:fld id="{B741DFA4-C744-40DA-B848-2124ADC83FCF}" type="datetimeFigureOut">
               <a:rPr lang="nl-BE" smtClean="0"/>
-              <a:t>23/08/2023</a:t>
+              <a:t>25/08/2023</a:t>
             </a:fld>
             <a:endParaRPr lang="nl-BE"/>
           </a:p>
@@ -2690,7 +2691,7 @@
           <a:p>
             <a:fld id="{B741DFA4-C744-40DA-B848-2124ADC83FCF}" type="datetimeFigureOut">
               <a:rPr lang="nl-BE" smtClean="0"/>
-              <a:t>23/08/2023</a:t>
+              <a:t>25/08/2023</a:t>
             </a:fld>
             <a:endParaRPr lang="nl-BE"/>
           </a:p>
@@ -2933,7 +2934,7 @@
           <a:p>
             <a:fld id="{B741DFA4-C744-40DA-B848-2124ADC83FCF}" type="datetimeFigureOut">
               <a:rPr lang="nl-BE" smtClean="0"/>
-              <a:t>23/08/2023</a:t>
+              <a:t>25/08/2023</a:t>
             </a:fld>
             <a:endParaRPr lang="nl-BE"/>
           </a:p>
@@ -5295,8 +5296,8 @@
         </p:nvSpPr>
         <p:spPr>
           <a:xfrm>
-            <a:off x="333702" y="4648378"/>
-            <a:ext cx="4715137" cy="2246769"/>
+            <a:off x="280868" y="4648378"/>
+            <a:ext cx="4820807" cy="2246769"/>
           </a:xfrm>
           <a:prstGeom prst="rect">
             <a:avLst/>
@@ -5391,7 +5392,7 @@
           <a:p>
             <a:r>
               <a:rPr lang="nl-BE" sz="1400" dirty="0"/>
-              <a:t> - </a:t>
+              <a:t>- </a:t>
             </a:r>
             <a:r>
               <a:rPr lang="nl-BE" sz="1400" dirty="0" err="1"/>
@@ -5421,7 +5422,7 @@
           <a:p>
             <a:r>
               <a:rPr lang="nl-BE" sz="1400" dirty="0"/>
-              <a:t> - in different </a:t>
+              <a:t>- in different </a:t>
             </a:r>
             <a:r>
               <a:rPr lang="nl-BE" sz="1400" dirty="0" err="1"/>
@@ -5451,7 +5452,7 @@
           <a:p>
             <a:r>
               <a:rPr lang="nl-BE" sz="1400" dirty="0"/>
-              <a:t> - </a:t>
+              <a:t>- </a:t>
             </a:r>
             <a:r>
               <a:rPr lang="nl-BE" sz="1400" dirty="0" err="1"/>
@@ -5501,11 +5502,19 @@
             </a:r>
             <a:r>
               <a:rPr lang="nl-BE" sz="1400" dirty="0" err="1"/>
-              <a:t>pearsons</a:t>
+              <a:t>puncta</a:t>
             </a:r>
             <a:r>
               <a:rPr lang="nl-BE" sz="1400" dirty="0"/>
-              <a:t>, …</a:t>
+              <a:t> </a:t>
+            </a:r>
+            <a:r>
+              <a:rPr lang="nl-BE" sz="1400" dirty="0" err="1"/>
+              <a:t>density</a:t>
+            </a:r>
+            <a:r>
+              <a:rPr lang="nl-BE" sz="1400" dirty="0"/>
+              <a:t>…</a:t>
             </a:r>
           </a:p>
           <a:p>
@@ -10045,8 +10054,8 @@
         </p:nvSpPr>
         <p:spPr>
           <a:xfrm>
-            <a:off x="2572787" y="390525"/>
-            <a:ext cx="7591792" cy="3381375"/>
+            <a:off x="2572787" y="331531"/>
+            <a:ext cx="8067740" cy="3381375"/>
           </a:xfrm>
           <a:prstGeom prst="roundRect">
             <a:avLst/>
@@ -10485,8 +10494,8 @@
         </p:nvSpPr>
         <p:spPr>
           <a:xfrm>
-            <a:off x="3280271" y="1607361"/>
-            <a:ext cx="1010212" cy="430887"/>
+            <a:off x="3391682" y="1607361"/>
+            <a:ext cx="787395" cy="430887"/>
           </a:xfrm>
           <a:prstGeom prst="rect">
             <a:avLst/>
@@ -10506,23 +10515,7 @@
                   <a:schemeClr val="bg1"/>
                 </a:solidFill>
               </a:rPr>
-              <a:t>Extracting</a:t>
-            </a:r>
-            <a:r>
-              <a:rPr lang="nl-BE" sz="1100" dirty="0">
-                <a:solidFill>
-                  <a:schemeClr val="bg1"/>
-                </a:solidFill>
-              </a:rPr>
-              <a:t> </a:t>
-            </a:r>
-            <a:r>
-              <a:rPr lang="nl-BE" sz="1100" dirty="0" err="1">
-                <a:solidFill>
-                  <a:schemeClr val="bg1"/>
-                </a:solidFill>
-              </a:rPr>
-              <a:t>the</a:t>
+              <a:t>Calculate</a:t>
             </a:r>
             <a:r>
               <a:rPr lang="nl-BE" sz="1100" dirty="0">
@@ -10598,7 +10591,7 @@
         <p:spPr>
           <a:xfrm>
             <a:off x="4397883" y="1913001"/>
-            <a:ext cx="1355490" cy="0"/>
+            <a:ext cx="946806" cy="0"/>
           </a:xfrm>
           <a:prstGeom prst="straightConnector1">
             <a:avLst/>
@@ -10764,8 +10757,8 @@
         </p:nvCxnSpPr>
         <p:spPr>
           <a:xfrm>
-            <a:off x="7032007" y="2281992"/>
-            <a:ext cx="1576822" cy="0"/>
+            <a:off x="6599454" y="1904077"/>
+            <a:ext cx="915779" cy="8924"/>
           </a:xfrm>
           <a:prstGeom prst="straightConnector1">
             <a:avLst/>
@@ -10807,7 +10800,7 @@
         <p:spPr>
           <a:xfrm>
             <a:off x="3293806" y="362631"/>
-            <a:ext cx="6449962" cy="584775"/>
+            <a:ext cx="6662948" cy="584775"/>
           </a:xfrm>
           <a:prstGeom prst="rect">
             <a:avLst/>
@@ -10851,7 +10844,7 @@
                   <a:schemeClr val="bg1"/>
                 </a:solidFill>
               </a:rPr>
-              <a:t> image analysis pipeline - </a:t>
+              <a:t> image analysis pipeline – </a:t>
             </a:r>
             <a:r>
               <a:rPr lang="nl-BE" sz="2000" dirty="0" err="1">
@@ -10861,11 +10854,14 @@
               </a:rPr>
               <a:t>surrogate</a:t>
             </a:r>
-            <a:endParaRPr lang="nl-BE" sz="2000" dirty="0">
-              <a:solidFill>
-                <a:schemeClr val="bg1"/>
-              </a:solidFill>
-            </a:endParaRPr>
+            <a:r>
+              <a:rPr lang="nl-BE" sz="2000" dirty="0">
+                <a:solidFill>
+                  <a:schemeClr val="bg1"/>
+                </a:solidFill>
+              </a:rPr>
+              <a:t> pipeline</a:t>
+            </a:r>
           </a:p>
           <a:p>
             <a:pPr algn="ctr"/>
@@ -10936,13 +10932,14 @@
           </p:cNvPr>
           <p:cNvCxnSpPr>
             <a:cxnSpLocks/>
+            <a:stCxn id="30" idx="2"/>
           </p:cNvCxnSpPr>
           <p:nvPr/>
         </p:nvCxnSpPr>
         <p:spPr>
           <a:xfrm>
-            <a:off x="7413685" y="2502982"/>
-            <a:ext cx="0" cy="1262568"/>
+            <a:off x="6991229" y="2118015"/>
+            <a:ext cx="0" cy="1647535"/>
           </a:xfrm>
           <a:prstGeom prst="straightConnector1">
             <a:avLst/>
@@ -10983,7 +10980,7 @@
         </p:nvSpPr>
         <p:spPr>
           <a:xfrm>
-            <a:off x="5780105" y="1607361"/>
+            <a:off x="5349644" y="1601898"/>
             <a:ext cx="1249810" cy="1174716"/>
           </a:xfrm>
           <a:prstGeom prst="roundRect">
@@ -11045,7 +11042,7 @@
         </p:blipFill>
         <p:spPr>
           <a:xfrm>
-            <a:off x="6183760" y="2041987"/>
+            <a:off x="5753299" y="2036524"/>
             <a:ext cx="489335" cy="500513"/>
           </a:xfrm>
           <a:prstGeom prst="rect">
@@ -11067,7 +11064,7 @@
         </p:nvSpPr>
         <p:spPr>
           <a:xfrm>
-            <a:off x="5876046" y="1607360"/>
+            <a:off x="5445585" y="1601897"/>
             <a:ext cx="1096774" cy="430887"/>
           </a:xfrm>
           <a:prstGeom prst="rect">
@@ -11147,8 +11144,8 @@
         </p:nvSpPr>
         <p:spPr>
           <a:xfrm>
-            <a:off x="4413951" y="1113851"/>
-            <a:ext cx="1000595" cy="430887"/>
+            <a:off x="4372713" y="1209483"/>
+            <a:ext cx="1000595" cy="261610"/>
           </a:xfrm>
           <a:prstGeom prst="rect">
             <a:avLst/>
@@ -11156,7 +11153,7 @@
           <a:noFill/>
         </p:spPr>
         <p:txBody>
-          <a:bodyPr wrap="none" rtlCol="0">
+          <a:bodyPr wrap="square" rtlCol="0">
             <a:spAutoFit/>
           </a:bodyPr>
           <a:lstStyle/>
@@ -11171,17 +11168,6 @@
               <a:t>thresholds.csv</a:t>
             </a:r>
           </a:p>
-          <a:p>
-            <a:pPr algn="ctr"/>
-            <a:r>
-              <a:rPr lang="nl-BE" sz="1100" dirty="0">
-                <a:solidFill>
-                  <a:schemeClr val="bg1"/>
-                </a:solidFill>
-              </a:rPr>
-              <a:t>spots.tiff</a:t>
-            </a:r>
-          </a:p>
         </p:txBody>
       </p:sp>
       <p:sp>
@@ -11198,7 +11184,7 @@
         </p:nvSpPr>
         <p:spPr>
           <a:xfrm>
-            <a:off x="7005406" y="1368182"/>
+            <a:off x="6424385" y="1161173"/>
             <a:ext cx="1367683" cy="261610"/>
           </a:xfrm>
           <a:prstGeom prst="rect">
@@ -11238,7 +11224,7 @@
         </p:nvSpPr>
         <p:spPr>
           <a:xfrm>
-            <a:off x="8626108" y="1603353"/>
+            <a:off x="7515233" y="1592309"/>
             <a:ext cx="1249810" cy="1174716"/>
           </a:xfrm>
           <a:prstGeom prst="roundRect">
@@ -11300,7 +11286,7 @@
         </p:blipFill>
         <p:spPr>
           <a:xfrm>
-            <a:off x="9029763" y="2037979"/>
+            <a:off x="7918888" y="2026935"/>
             <a:ext cx="489335" cy="500513"/>
           </a:xfrm>
           <a:prstGeom prst="rect">
@@ -11322,8 +11308,8 @@
         </p:nvSpPr>
         <p:spPr>
           <a:xfrm>
-            <a:off x="8819038" y="1603352"/>
-            <a:ext cx="902811" cy="430887"/>
+            <a:off x="7789115" y="1592308"/>
+            <a:ext cx="740907" cy="430887"/>
           </a:xfrm>
           <a:prstGeom prst="rect">
             <a:avLst/>
@@ -11362,7 +11348,7 @@
                   <a:schemeClr val="bg1"/>
                 </a:solidFill>
               </a:rPr>
-              <a:t>overlap area</a:t>
+              <a:t>overlap</a:t>
             </a:r>
           </a:p>
         </p:txBody>
@@ -11389,7 +11375,7 @@
         </p:blipFill>
         <p:spPr>
           <a:xfrm>
-            <a:off x="7152233" y="1930881"/>
+            <a:off x="6729227" y="1555482"/>
             <a:ext cx="524004" cy="562533"/>
           </a:xfrm>
           <a:prstGeom prst="rect">
@@ -11413,7 +11399,7 @@
         </p:nvCxnSpPr>
         <p:spPr>
           <a:xfrm>
-            <a:off x="9875918" y="2281992"/>
+            <a:off x="8765043" y="2190268"/>
             <a:ext cx="288661" cy="0"/>
           </a:xfrm>
           <a:prstGeom prst="straightConnector1">
@@ -11583,7 +11569,7 @@
         <p:spPr>
           <a:xfrm>
             <a:off x="2804929" y="3206750"/>
-            <a:ext cx="5632450" cy="0"/>
+            <a:ext cx="4538854" cy="0"/>
           </a:xfrm>
           <a:prstGeom prst="line">
             <a:avLst/>
@@ -11625,7 +11611,7 @@
         </p:nvCxnSpPr>
         <p:spPr>
           <a:xfrm>
-            <a:off x="8437379" y="2370789"/>
+            <a:off x="7343783" y="2379708"/>
             <a:ext cx="0" cy="835961"/>
           </a:xfrm>
           <a:prstGeom prst="line">
@@ -11666,7 +11652,7 @@
         </p:nvCxnSpPr>
         <p:spPr>
           <a:xfrm>
-            <a:off x="8437379" y="2370789"/>
+            <a:off x="7343783" y="2379708"/>
             <a:ext cx="171450" cy="0"/>
           </a:xfrm>
           <a:prstGeom prst="straightConnector1">
@@ -11696,36 +11682,6 @@
       </p:cxnSp>
       <p:pic>
         <p:nvPicPr>
-          <p:cNvPr id="87" name="Picture 86">
-            <a:extLst>
-              <a:ext uri="{FF2B5EF4-FFF2-40B4-BE49-F238E27FC236}">
-                <a16:creationId xmlns:a16="http://schemas.microsoft.com/office/drawing/2014/main" id="{66B5FC2D-EA49-49B3-A493-4E1B718E29A7}"/>
-              </a:ext>
-            </a:extLst>
-          </p:cNvPr>
-          <p:cNvPicPr>
-            <a:picLocks noChangeAspect="1"/>
-          </p:cNvPicPr>
-          <p:nvPr/>
-        </p:nvPicPr>
-        <p:blipFill>
-          <a:blip r:embed="rId4"/>
-          <a:stretch>
-            <a:fillRect/>
-          </a:stretch>
-        </p:blipFill>
-        <p:spPr>
-          <a:xfrm>
-            <a:off x="10535477" y="2146868"/>
-            <a:ext cx="508808" cy="562533"/>
-          </a:xfrm>
-          <a:prstGeom prst="rect">
-            <a:avLst/>
-          </a:prstGeom>
-        </p:spPr>
-      </p:pic>
-      <p:pic>
-        <p:nvPicPr>
           <p:cNvPr id="88" name="Picture 87">
             <a:extLst>
               <a:ext uri="{FF2B5EF4-FFF2-40B4-BE49-F238E27FC236}">
@@ -11746,7 +11702,7 @@
         </p:blipFill>
         <p:spPr>
           <a:xfrm>
-            <a:off x="11193280" y="2143551"/>
+            <a:off x="10975734" y="1471093"/>
             <a:ext cx="524004" cy="562533"/>
           </a:xfrm>
           <a:prstGeom prst="rect">
@@ -11768,7 +11724,7 @@
         </p:nvSpPr>
         <p:spPr>
           <a:xfrm>
-            <a:off x="10702929" y="1544738"/>
+            <a:off x="10743536" y="1237732"/>
             <a:ext cx="891591" cy="261610"/>
           </a:xfrm>
           <a:prstGeom prst="rect">
@@ -11785,17 +11741,17 @@
             <a:pPr algn="ctr"/>
             <a:r>
               <a:rPr lang="nl-BE" sz="1100" dirty="0"/>
-              <a:t>	statistics.csv</a:t>
-            </a:r>
-          </a:p>
-        </p:txBody>
-      </p:sp>
-      <p:sp>
-        <p:nvSpPr>
-          <p:cNvPr id="90" name="TextBox 89">
-            <a:extLst>
-              <a:ext uri="{FF2B5EF4-FFF2-40B4-BE49-F238E27FC236}">
-                <a16:creationId xmlns:a16="http://schemas.microsoft.com/office/drawing/2014/main" id="{6FDB57BA-41F1-4D5D-9213-E45EF1CF560D}"/>
+              <a:t>	overlap.csv</a:t>
+            </a:r>
+          </a:p>
+        </p:txBody>
+      </p:sp>
+      <p:sp>
+        <p:nvSpPr>
+          <p:cNvPr id="91" name="TextBox 90">
+            <a:extLst>
+              <a:ext uri="{FF2B5EF4-FFF2-40B4-BE49-F238E27FC236}">
+                <a16:creationId xmlns:a16="http://schemas.microsoft.com/office/drawing/2014/main" id="{5A5DDA7D-8719-4F85-A2ED-F724BC1430FA}"/>
               </a:ext>
             </a:extLst>
           </p:cNvPr>
@@ -11804,8 +11760,8 @@
         </p:nvSpPr>
         <p:spPr>
           <a:xfrm>
-            <a:off x="10597132" y="1771405"/>
-            <a:ext cx="1103187" cy="261610"/>
+            <a:off x="10844347" y="2263149"/>
+            <a:ext cx="853119" cy="261610"/>
           </a:xfrm>
           <a:prstGeom prst="rect">
             <a:avLst/>
@@ -11821,43 +11777,7 @@
             <a:pPr algn="ctr"/>
             <a:r>
               <a:rPr lang="nl-BE" sz="1100" dirty="0"/>
-              <a:t>	statistics_fig.csv</a:t>
-            </a:r>
-          </a:p>
-        </p:txBody>
-      </p:sp>
-      <p:sp>
-        <p:nvSpPr>
-          <p:cNvPr id="91" name="TextBox 90">
-            <a:extLst>
-              <a:ext uri="{FF2B5EF4-FFF2-40B4-BE49-F238E27FC236}">
-                <a16:creationId xmlns:a16="http://schemas.microsoft.com/office/drawing/2014/main" id="{5A5DDA7D-8719-4F85-A2ED-F724BC1430FA}"/>
-              </a:ext>
-            </a:extLst>
-          </p:cNvPr>
-          <p:cNvSpPr txBox="1"/>
-          <p:nvPr/>
-        </p:nvSpPr>
-        <p:spPr>
-          <a:xfrm>
-            <a:off x="10633671" y="2954059"/>
-            <a:ext cx="1119217" cy="261610"/>
-          </a:xfrm>
-          <a:prstGeom prst="rect">
-            <a:avLst/>
-          </a:prstGeom>
-          <a:noFill/>
-        </p:spPr>
-        <p:txBody>
-          <a:bodyPr wrap="none" rtlCol="0">
-            <a:spAutoFit/>
-          </a:bodyPr>
-          <a:lstStyle/>
-          <a:p>
-            <a:pPr algn="ctr"/>
-            <a:r>
-              <a:rPr lang="nl-BE" sz="1100" dirty="0"/>
-              <a:t>	image_spots.csv</a:t>
+              <a:t>dotplot.png</a:t>
             </a:r>
           </a:p>
         </p:txBody>
@@ -11936,12 +11856,346 @@
           </a:prstGeom>
         </p:spPr>
       </p:pic>
+      <p:sp>
+        <p:nvSpPr>
+          <p:cNvPr id="99" name="TextBox 98">
+            <a:extLst>
+              <a:ext uri="{FF2B5EF4-FFF2-40B4-BE49-F238E27FC236}">
+                <a16:creationId xmlns:a16="http://schemas.microsoft.com/office/drawing/2014/main" id="{1FD5B65E-31E6-4F10-92DC-F88AECB373E7}"/>
+              </a:ext>
+            </a:extLst>
+          </p:cNvPr>
+          <p:cNvSpPr txBox="1"/>
+          <p:nvPr/>
+        </p:nvSpPr>
+        <p:spPr>
+          <a:xfrm>
+            <a:off x="10730981" y="912769"/>
+            <a:ext cx="835485" cy="338554"/>
+          </a:xfrm>
+          <a:prstGeom prst="rect">
+            <a:avLst/>
+          </a:prstGeom>
+          <a:noFill/>
+        </p:spPr>
+        <p:txBody>
+          <a:bodyPr wrap="none" rtlCol="0">
+            <a:spAutoFit/>
+          </a:bodyPr>
+          <a:lstStyle/>
+          <a:p>
+            <a:r>
+              <a:rPr lang="nl-BE" sz="1600" dirty="0"/>
+              <a:t>Output:</a:t>
+            </a:r>
+          </a:p>
+        </p:txBody>
+      </p:sp>
+      <p:cxnSp>
+        <p:nvCxnSpPr>
+          <p:cNvPr id="103" name="Straight Connector 102">
+            <a:extLst>
+              <a:ext uri="{FF2B5EF4-FFF2-40B4-BE49-F238E27FC236}">
+                <a16:creationId xmlns:a16="http://schemas.microsoft.com/office/drawing/2014/main" id="{166508AB-3D99-48DF-9CD8-8414F5BCF3A0}"/>
+              </a:ext>
+            </a:extLst>
+          </p:cNvPr>
+          <p:cNvCxnSpPr/>
+          <p:nvPr/>
+        </p:nvCxnSpPr>
+        <p:spPr>
+          <a:xfrm>
+            <a:off x="2572787" y="944519"/>
+            <a:ext cx="7591792" cy="0"/>
+          </a:xfrm>
+          <a:prstGeom prst="line">
+            <a:avLst/>
+          </a:prstGeom>
+          <a:ln>
+            <a:solidFill>
+              <a:schemeClr val="bg1"/>
+            </a:solidFill>
+          </a:ln>
+        </p:spPr>
+        <p:style>
+          <a:lnRef idx="1">
+            <a:schemeClr val="accent1"/>
+          </a:lnRef>
+          <a:fillRef idx="0">
+            <a:schemeClr val="accent1"/>
+          </a:fillRef>
+          <a:effectRef idx="0">
+            <a:schemeClr val="accent1"/>
+          </a:effectRef>
+          <a:fontRef idx="minor">
+            <a:schemeClr val="tx1"/>
+          </a:fontRef>
+        </p:style>
+      </p:cxnSp>
       <p:pic>
         <p:nvPicPr>
-          <p:cNvPr id="98" name="Picture 97">
-            <a:extLst>
-              <a:ext uri="{FF2B5EF4-FFF2-40B4-BE49-F238E27FC236}">
-                <a16:creationId xmlns:a16="http://schemas.microsoft.com/office/drawing/2014/main" id="{6FB011A4-6D03-412A-91FE-D66BA2CC8C8C}"/>
+          <p:cNvPr id="109" name="Picture 108">
+            <a:extLst>
+              <a:ext uri="{FF2B5EF4-FFF2-40B4-BE49-F238E27FC236}">
+                <a16:creationId xmlns:a16="http://schemas.microsoft.com/office/drawing/2014/main" id="{2056B11B-6B45-496A-9D65-E4F1BB5DB290}"/>
+              </a:ext>
+            </a:extLst>
+          </p:cNvPr>
+          <p:cNvPicPr>
+            <a:picLocks noChangeAspect="1"/>
+          </p:cNvPicPr>
+          <p:nvPr/>
+        </p:nvPicPr>
+        <p:blipFill>
+          <a:blip r:embed="rId4"/>
+          <a:stretch>
+            <a:fillRect/>
+          </a:stretch>
+        </p:blipFill>
+        <p:spPr>
+          <a:xfrm>
+            <a:off x="174352" y="536129"/>
+            <a:ext cx="2184695" cy="846805"/>
+          </a:xfrm>
+          <a:prstGeom prst="rect">
+            <a:avLst/>
+          </a:prstGeom>
+        </p:spPr>
+      </p:pic>
+      <p:sp>
+        <p:nvSpPr>
+          <p:cNvPr id="6" name="Tekstvak 5">
+            <a:extLst>
+              <a:ext uri="{FF2B5EF4-FFF2-40B4-BE49-F238E27FC236}">
+                <a16:creationId xmlns:a16="http://schemas.microsoft.com/office/drawing/2014/main" id="{150A32B2-BE43-92C3-0D90-C0C7BE9F92F4}"/>
+              </a:ext>
+            </a:extLst>
+          </p:cNvPr>
+          <p:cNvSpPr txBox="1"/>
+          <p:nvPr/>
+        </p:nvSpPr>
+        <p:spPr>
+          <a:xfrm>
+            <a:off x="337335" y="46615"/>
+            <a:ext cx="1915396" cy="646331"/>
+          </a:xfrm>
+          <a:prstGeom prst="rect">
+            <a:avLst/>
+          </a:prstGeom>
+          <a:noFill/>
+        </p:spPr>
+        <p:txBody>
+          <a:bodyPr wrap="none" rtlCol="0">
+            <a:spAutoFit/>
+          </a:bodyPr>
+          <a:lstStyle/>
+          <a:p>
+            <a:pPr algn="ctr"/>
+            <a:r>
+              <a:rPr lang="en-US" b="1" dirty="0"/>
+              <a:t>Simplified </a:t>
+            </a:r>
+          </a:p>
+          <a:p>
+            <a:pPr algn="ctr"/>
+            <a:r>
+              <a:rPr lang="en-US" b="1" dirty="0"/>
+              <a:t>surrogate pipeline</a:t>
+            </a:r>
+            <a:endParaRPr lang="nl-NL" b="1" dirty="0"/>
+          </a:p>
+        </p:txBody>
+      </p:sp>
+      <p:sp>
+        <p:nvSpPr>
+          <p:cNvPr id="23" name="Rectangle: Rounded Corners 40">
+            <a:extLst>
+              <a:ext uri="{FF2B5EF4-FFF2-40B4-BE49-F238E27FC236}">
+                <a16:creationId xmlns:a16="http://schemas.microsoft.com/office/drawing/2014/main" id="{9E0400E2-B1B3-A488-AEFF-CE5AC5530EE0}"/>
+              </a:ext>
+            </a:extLst>
+          </p:cNvPr>
+          <p:cNvSpPr/>
+          <p:nvPr/>
+        </p:nvSpPr>
+        <p:spPr>
+          <a:xfrm>
+            <a:off x="9063764" y="1582338"/>
+            <a:ext cx="1249810" cy="1174716"/>
+          </a:xfrm>
+          <a:prstGeom prst="roundRect">
+            <a:avLst/>
+          </a:prstGeom>
+          <a:solidFill>
+            <a:schemeClr val="accent5">
+              <a:lumMod val="75000"/>
+            </a:schemeClr>
+          </a:solidFill>
+          <a:ln>
+            <a:noFill/>
+          </a:ln>
+        </p:spPr>
+        <p:style>
+          <a:lnRef idx="2">
+            <a:schemeClr val="accent1">
+              <a:shade val="50000"/>
+            </a:schemeClr>
+          </a:lnRef>
+          <a:fillRef idx="1">
+            <a:schemeClr val="accent1"/>
+          </a:fillRef>
+          <a:effectRef idx="0">
+            <a:schemeClr val="accent1"/>
+          </a:effectRef>
+          <a:fontRef idx="minor">
+            <a:schemeClr val="lt1"/>
+          </a:fontRef>
+        </p:style>
+        <p:txBody>
+          <a:bodyPr rtlCol="0" anchor="ctr"/>
+          <a:lstStyle/>
+          <a:p>
+            <a:pPr algn="ctr"/>
+            <a:endParaRPr lang="nl-BE"/>
+          </a:p>
+        </p:txBody>
+      </p:sp>
+      <p:pic>
+        <p:nvPicPr>
+          <p:cNvPr id="26" name="Picture 41">
+            <a:extLst>
+              <a:ext uri="{FF2B5EF4-FFF2-40B4-BE49-F238E27FC236}">
+                <a16:creationId xmlns:a16="http://schemas.microsoft.com/office/drawing/2014/main" id="{930AA0C1-55D1-DE21-7C82-7383DC262C69}"/>
+              </a:ext>
+            </a:extLst>
+          </p:cNvPr>
+          <p:cNvPicPr>
+            <a:picLocks noChangeAspect="1"/>
+          </p:cNvPicPr>
+          <p:nvPr/>
+        </p:nvPicPr>
+        <p:blipFill>
+          <a:blip r:embed="rId2"/>
+          <a:stretch>
+            <a:fillRect/>
+          </a:stretch>
+        </p:blipFill>
+        <p:spPr>
+          <a:xfrm>
+            <a:off x="9467419" y="2016964"/>
+            <a:ext cx="489335" cy="500513"/>
+          </a:xfrm>
+          <a:prstGeom prst="rect">
+            <a:avLst/>
+          </a:prstGeom>
+        </p:spPr>
+      </p:pic>
+      <p:sp>
+        <p:nvSpPr>
+          <p:cNvPr id="27" name="TextBox 42">
+            <a:extLst>
+              <a:ext uri="{FF2B5EF4-FFF2-40B4-BE49-F238E27FC236}">
+                <a16:creationId xmlns:a16="http://schemas.microsoft.com/office/drawing/2014/main" id="{A85C415F-A30D-67DC-E491-69F644724B03}"/>
+              </a:ext>
+            </a:extLst>
+          </p:cNvPr>
+          <p:cNvSpPr txBox="1"/>
+          <p:nvPr/>
+        </p:nvSpPr>
+        <p:spPr>
+          <a:xfrm>
+            <a:off x="9437833" y="1582337"/>
+            <a:ext cx="540534" cy="430887"/>
+          </a:xfrm>
+          <a:prstGeom prst="rect">
+            <a:avLst/>
+          </a:prstGeom>
+          <a:noFill/>
+        </p:spPr>
+        <p:txBody>
+          <a:bodyPr wrap="none" rtlCol="0">
+            <a:spAutoFit/>
+          </a:bodyPr>
+          <a:lstStyle/>
+          <a:p>
+            <a:pPr algn="ctr"/>
+            <a:r>
+              <a:rPr lang="nl-BE" sz="1100" dirty="0">
+                <a:solidFill>
+                  <a:schemeClr val="bg1"/>
+                </a:solidFill>
+              </a:rPr>
+              <a:t>Make</a:t>
+            </a:r>
+          </a:p>
+          <a:p>
+            <a:pPr algn="ctr"/>
+            <a:r>
+              <a:rPr lang="nl-BE" sz="1100" dirty="0" err="1">
+                <a:solidFill>
+                  <a:schemeClr val="bg1"/>
+                </a:solidFill>
+              </a:rPr>
+              <a:t>Figure</a:t>
+            </a:r>
+            <a:endParaRPr lang="nl-BE" sz="1100" dirty="0">
+              <a:solidFill>
+                <a:schemeClr val="bg1"/>
+              </a:solidFill>
+            </a:endParaRPr>
+          </a:p>
+        </p:txBody>
+      </p:sp>
+      <p:cxnSp>
+        <p:nvCxnSpPr>
+          <p:cNvPr id="32" name="Straight Arrow Connector 46">
+            <a:extLst>
+              <a:ext uri="{FF2B5EF4-FFF2-40B4-BE49-F238E27FC236}">
+                <a16:creationId xmlns:a16="http://schemas.microsoft.com/office/drawing/2014/main" id="{58355587-E15F-1019-41D0-DD485BC73B7A}"/>
+              </a:ext>
+            </a:extLst>
+          </p:cNvPr>
+          <p:cNvCxnSpPr>
+            <a:cxnSpLocks/>
+          </p:cNvCxnSpPr>
+          <p:nvPr/>
+        </p:nvCxnSpPr>
+        <p:spPr>
+          <a:xfrm>
+            <a:off x="10313574" y="1968500"/>
+            <a:ext cx="288661" cy="0"/>
+          </a:xfrm>
+          <a:prstGeom prst="straightConnector1">
+            <a:avLst/>
+          </a:prstGeom>
+          <a:ln>
+            <a:solidFill>
+              <a:schemeClr val="bg1"/>
+            </a:solidFill>
+            <a:tailEnd type="triangle"/>
+          </a:ln>
+        </p:spPr>
+        <p:style>
+          <a:lnRef idx="1">
+            <a:schemeClr val="accent1"/>
+          </a:lnRef>
+          <a:fillRef idx="0">
+            <a:schemeClr val="accent1"/>
+          </a:fillRef>
+          <a:effectRef idx="0">
+            <a:schemeClr val="accent1"/>
+          </a:effectRef>
+          <a:fontRef idx="minor">
+            <a:schemeClr val="tx1"/>
+          </a:fontRef>
+        </p:style>
+      </p:cxnSp>
+      <p:pic>
+        <p:nvPicPr>
+          <p:cNvPr id="34" name="Picture 86">
+            <a:extLst>
+              <a:ext uri="{FF2B5EF4-FFF2-40B4-BE49-F238E27FC236}">
+                <a16:creationId xmlns:a16="http://schemas.microsoft.com/office/drawing/2014/main" id="{7E8EA08F-F511-3108-E391-205DECB0F293}"/>
               </a:ext>
             </a:extLst>
           </p:cNvPr>
@@ -11958,8 +12212,8 @@
         </p:blipFill>
         <p:spPr>
           <a:xfrm>
-            <a:off x="10949157" y="3218986"/>
-            <a:ext cx="495101" cy="544457"/>
+            <a:off x="11016502" y="2506573"/>
+            <a:ext cx="508808" cy="562533"/>
           </a:xfrm>
           <a:prstGeom prst="rect">
             <a:avLst/>
@@ -11968,10 +12222,10 @@
       </p:pic>
       <p:sp>
         <p:nvSpPr>
-          <p:cNvPr id="99" name="TextBox 98">
-            <a:extLst>
-              <a:ext uri="{FF2B5EF4-FFF2-40B4-BE49-F238E27FC236}">
-                <a16:creationId xmlns:a16="http://schemas.microsoft.com/office/drawing/2014/main" id="{1FD5B65E-31E6-4F10-92DC-F88AECB373E7}"/>
+          <p:cNvPr id="36" name="TextBox 4">
+            <a:extLst>
+              <a:ext uri="{FF2B5EF4-FFF2-40B4-BE49-F238E27FC236}">
+                <a16:creationId xmlns:a16="http://schemas.microsoft.com/office/drawing/2014/main" id="{3E4E1008-E432-9F68-5328-F601E8697D78}"/>
               </a:ext>
             </a:extLst>
           </p:cNvPr>
@@ -11980,8 +12234,8 @@
         </p:nvSpPr>
         <p:spPr>
           <a:xfrm>
-            <a:off x="10730981" y="912769"/>
-            <a:ext cx="835485" cy="338554"/>
+            <a:off x="881222" y="1422783"/>
+            <a:ext cx="681597" cy="338554"/>
           </a:xfrm>
           <a:prstGeom prst="rect">
             <a:avLst/>
@@ -11996,17 +12250,17 @@
           <a:p>
             <a:r>
               <a:rPr lang="nl-BE" sz="1600" dirty="0"/>
-              <a:t>Output:</a:t>
-            </a:r>
-          </a:p>
-        </p:txBody>
-      </p:sp>
-      <p:sp>
-        <p:nvSpPr>
-          <p:cNvPr id="100" name="TextBox 99">
-            <a:extLst>
-              <a:ext uri="{FF2B5EF4-FFF2-40B4-BE49-F238E27FC236}">
-                <a16:creationId xmlns:a16="http://schemas.microsoft.com/office/drawing/2014/main" id="{9594E085-5AB5-48E5-B43E-42D10D0C0C0A}"/>
+              <a:t>Input:</a:t>
+            </a:r>
+          </a:p>
+        </p:txBody>
+      </p:sp>
+      <p:sp>
+        <p:nvSpPr>
+          <p:cNvPr id="40" name="TextBox 4">
+            <a:extLst>
+              <a:ext uri="{FF2B5EF4-FFF2-40B4-BE49-F238E27FC236}">
+                <a16:creationId xmlns:a16="http://schemas.microsoft.com/office/drawing/2014/main" id="{40E7755C-6E36-47B2-1628-58F8FA7C70DC}"/>
               </a:ext>
             </a:extLst>
           </p:cNvPr>
@@ -12015,8 +12269,8 @@
         </p:nvSpPr>
         <p:spPr>
           <a:xfrm>
-            <a:off x="1239193" y="4545147"/>
-            <a:ext cx="2239716" cy="430887"/>
+            <a:off x="241633" y="5030915"/>
+            <a:ext cx="11465831" cy="1077218"/>
           </a:xfrm>
           <a:prstGeom prst="rect">
             <a:avLst/>
@@ -12031,395 +12285,226 @@
           <a:p>
             <a:pPr algn="ctr"/>
             <a:r>
-              <a:rPr lang="nl-BE" sz="1100" dirty="0"/>
-              <a:t>opt-param.csv</a:t>
-            </a:r>
-          </a:p>
-          <a:p>
-            <a:pPr algn="ctr"/>
-            <a:r>
-              <a:rPr lang="nl-BE" sz="1100" i="1" dirty="0" err="1"/>
-              <a:t>Thresholds</a:t>
-            </a:r>
-            <a:r>
-              <a:rPr lang="nl-BE" sz="1100" i="1" dirty="0"/>
+              <a:rPr lang="nl-BE" sz="1600" b="1" dirty="0" err="1"/>
+              <a:t>Simplified</a:t>
+            </a:r>
+            <a:r>
+              <a:rPr lang="nl-BE" sz="1600" b="1" dirty="0"/>
               <a:t> </a:t>
             </a:r>
             <a:r>
-              <a:rPr lang="nl-BE" sz="1100" i="1" dirty="0" err="1"/>
-              <a:t>for</a:t>
-            </a:r>
-            <a:r>
-              <a:rPr lang="nl-BE" sz="1100" i="1" dirty="0"/>
+              <a:rPr lang="nl-BE" sz="1600" b="1" dirty="0" err="1"/>
+              <a:t>operation</a:t>
+            </a:r>
+            <a:r>
+              <a:rPr lang="nl-BE" sz="1600" b="1" dirty="0"/>
+              <a:t> on images:</a:t>
+            </a:r>
+          </a:p>
+          <a:p>
+            <a:endParaRPr lang="nl-BE" sz="1600" dirty="0"/>
+          </a:p>
+          <a:p>
+            <a:r>
+              <a:rPr lang="nl-BE" sz="1600" dirty="0"/>
+              <a:t>Preprocessing </a:t>
+            </a:r>
+            <a:r>
+              <a:rPr lang="nl-BE" sz="1600" dirty="0">
+                <a:sym typeface="Wingdings" panose="05000000000000000000" pitchFamily="2" charset="2"/>
+              </a:rPr>
+              <a:t> </a:t>
+            </a:r>
+            <a:r>
+              <a:rPr lang="nl-BE" sz="1600" dirty="0" err="1">
+                <a:sym typeface="Wingdings" panose="05000000000000000000" pitchFamily="2" charset="2"/>
+              </a:rPr>
+              <a:t>autothreshold</a:t>
+            </a:r>
+            <a:r>
+              <a:rPr lang="nl-BE" sz="1600" dirty="0">
+                <a:sym typeface="Wingdings" panose="05000000000000000000" pitchFamily="2" charset="2"/>
+              </a:rPr>
+              <a:t> (</a:t>
+            </a:r>
+            <a:r>
+              <a:rPr lang="nl-BE" sz="1600" dirty="0" err="1">
+                <a:sym typeface="Wingdings" panose="05000000000000000000" pitchFamily="2" charset="2"/>
+              </a:rPr>
+              <a:t>traingle</a:t>
+            </a:r>
+            <a:r>
+              <a:rPr lang="nl-BE" sz="1600" dirty="0">
+                <a:sym typeface="Wingdings" panose="05000000000000000000" pitchFamily="2" charset="2"/>
+              </a:rPr>
+              <a:t>)  </a:t>
+            </a:r>
+            <a:r>
+              <a:rPr lang="nl-BE" sz="1600" dirty="0" err="1">
+                <a:sym typeface="Wingdings" panose="05000000000000000000" pitchFamily="2" charset="2"/>
+              </a:rPr>
+              <a:t>calculate</a:t>
+            </a:r>
+            <a:r>
+              <a:rPr lang="nl-BE" sz="1600" dirty="0">
+                <a:sym typeface="Wingdings" panose="05000000000000000000" pitchFamily="2" charset="2"/>
+              </a:rPr>
+              <a:t> overlap (</a:t>
+            </a:r>
+            <a:r>
+              <a:rPr lang="nl-BE" sz="1600" dirty="0" err="1">
+                <a:sym typeface="Wingdings" panose="05000000000000000000" pitchFamily="2" charset="2"/>
+              </a:rPr>
+              <a:t>with</a:t>
+            </a:r>
+            <a:r>
+              <a:rPr lang="nl-BE" sz="1600" dirty="0">
+                <a:sym typeface="Wingdings" panose="05000000000000000000" pitchFamily="2" charset="2"/>
+              </a:rPr>
               <a:t> </a:t>
             </a:r>
             <a:r>
-              <a:rPr lang="nl-BE" sz="1100" i="1" dirty="0" err="1"/>
-              <a:t>each</a:t>
-            </a:r>
-            <a:r>
-              <a:rPr lang="nl-BE" sz="1100" i="1" dirty="0"/>
+              <a:rPr lang="nl-BE" sz="1600" dirty="0" err="1">
+                <a:sym typeface="Wingdings" panose="05000000000000000000" pitchFamily="2" charset="2"/>
+              </a:rPr>
+              <a:t>internal</a:t>
+            </a:r>
+            <a:r>
+              <a:rPr lang="nl-BE" sz="1600" dirty="0">
+                <a:sym typeface="Wingdings" panose="05000000000000000000" pitchFamily="2" charset="2"/>
+              </a:rPr>
               <a:t> </a:t>
             </a:r>
             <a:r>
-              <a:rPr lang="nl-BE" sz="1100" i="1" dirty="0" err="1"/>
-              <a:t>imported</a:t>
-            </a:r>
-            <a:r>
-              <a:rPr lang="nl-BE" sz="1100" i="1" dirty="0"/>
-              <a:t> image</a:t>
-            </a:r>
-          </a:p>
-        </p:txBody>
-      </p:sp>
-      <p:cxnSp>
-        <p:nvCxnSpPr>
-          <p:cNvPr id="103" name="Straight Connector 102">
-            <a:extLst>
-              <a:ext uri="{FF2B5EF4-FFF2-40B4-BE49-F238E27FC236}">
-                <a16:creationId xmlns:a16="http://schemas.microsoft.com/office/drawing/2014/main" id="{166508AB-3D99-48DF-9CD8-8414F5BCF3A0}"/>
-              </a:ext>
-            </a:extLst>
-          </p:cNvPr>
-          <p:cNvCxnSpPr/>
-          <p:nvPr/>
-        </p:nvCxnSpPr>
-        <p:spPr>
-          <a:xfrm>
-            <a:off x="2572787" y="944519"/>
-            <a:ext cx="7591792" cy="0"/>
-          </a:xfrm>
-          <a:prstGeom prst="line">
-            <a:avLst/>
-          </a:prstGeom>
-          <a:ln>
-            <a:solidFill>
-              <a:schemeClr val="bg1"/>
-            </a:solidFill>
-          </a:ln>
-        </p:spPr>
-        <p:style>
-          <a:lnRef idx="1">
-            <a:schemeClr val="accent1"/>
-          </a:lnRef>
-          <a:fillRef idx="0">
-            <a:schemeClr val="accent1"/>
-          </a:fillRef>
-          <a:effectRef idx="0">
-            <a:schemeClr val="accent1"/>
-          </a:effectRef>
-          <a:fontRef idx="minor">
-            <a:schemeClr val="tx1"/>
-          </a:fontRef>
-        </p:style>
-      </p:cxnSp>
-      <p:sp>
-        <p:nvSpPr>
-          <p:cNvPr id="104" name="Rectangle 103">
-            <a:extLst>
-              <a:ext uri="{FF2B5EF4-FFF2-40B4-BE49-F238E27FC236}">
-                <a16:creationId xmlns:a16="http://schemas.microsoft.com/office/drawing/2014/main" id="{A9ECAC5B-07A4-4A42-BCEC-7A4098F5FDBF}"/>
-              </a:ext>
-            </a:extLst>
-          </p:cNvPr>
-          <p:cNvSpPr/>
-          <p:nvPr/>
-        </p:nvSpPr>
-        <p:spPr>
-          <a:xfrm>
-            <a:off x="5344689" y="4530842"/>
-            <a:ext cx="2034532" cy="430887"/>
+              <a:rPr lang="nl-BE" sz="1600" dirty="0" err="1">
+                <a:sym typeface="Wingdings" panose="05000000000000000000" pitchFamily="2" charset="2"/>
+              </a:rPr>
+              <a:t>rotated</a:t>
+            </a:r>
+            <a:r>
+              <a:rPr lang="nl-BE" sz="1600" dirty="0">
+                <a:sym typeface="Wingdings" panose="05000000000000000000" pitchFamily="2" charset="2"/>
+              </a:rPr>
+              <a:t> </a:t>
+            </a:r>
+            <a:r>
+              <a:rPr lang="nl-BE" sz="1600" dirty="0" err="1">
+                <a:sym typeface="Wingdings" panose="05000000000000000000" pitchFamily="2" charset="2"/>
+              </a:rPr>
+              <a:t>cntrl</a:t>
+            </a:r>
+            <a:r>
+              <a:rPr lang="nl-BE" sz="1600" dirty="0">
+                <a:sym typeface="Wingdings" panose="05000000000000000000" pitchFamily="2" charset="2"/>
+              </a:rPr>
+              <a:t>)  </a:t>
+            </a:r>
+            <a:r>
+              <a:rPr lang="nl-BE" sz="1600" dirty="0" err="1">
+                <a:sym typeface="Wingdings" panose="05000000000000000000" pitchFamily="2" charset="2"/>
+              </a:rPr>
+              <a:t>calculate</a:t>
+            </a:r>
+            <a:r>
+              <a:rPr lang="nl-BE" sz="1600" dirty="0">
+                <a:sym typeface="Wingdings" panose="05000000000000000000" pitchFamily="2" charset="2"/>
+              </a:rPr>
+              <a:t> </a:t>
+            </a:r>
+            <a:r>
+              <a:rPr lang="nl-BE" sz="1600" dirty="0" err="1">
+                <a:sym typeface="Wingdings" panose="05000000000000000000" pitchFamily="2" charset="2"/>
+              </a:rPr>
+              <a:t>mean</a:t>
+            </a:r>
+            <a:r>
+              <a:rPr lang="nl-BE" sz="1600" dirty="0">
+                <a:sym typeface="Wingdings" panose="05000000000000000000" pitchFamily="2" charset="2"/>
+              </a:rPr>
+              <a:t> overlap  </a:t>
+            </a:r>
+            <a:r>
+              <a:rPr lang="nl-BE" sz="1600" dirty="0" err="1">
+                <a:sym typeface="Wingdings" panose="05000000000000000000" pitchFamily="2" charset="2"/>
+              </a:rPr>
+              <a:t>apply</a:t>
+            </a:r>
+            <a:r>
+              <a:rPr lang="nl-BE" sz="1600" dirty="0">
+                <a:sym typeface="Wingdings" panose="05000000000000000000" pitchFamily="2" charset="2"/>
+              </a:rPr>
+              <a:t> </a:t>
+            </a:r>
+            <a:r>
+              <a:rPr lang="nl-BE" sz="1600" dirty="0" err="1">
+                <a:sym typeface="Wingdings" panose="05000000000000000000" pitchFamily="2" charset="2"/>
+              </a:rPr>
+              <a:t>to</a:t>
+            </a:r>
+            <a:r>
+              <a:rPr lang="nl-BE" sz="1600" dirty="0">
+                <a:sym typeface="Wingdings" panose="05000000000000000000" pitchFamily="2" charset="2"/>
+              </a:rPr>
+              <a:t> images</a:t>
+            </a:r>
+          </a:p>
+          <a:p>
+            <a:r>
+              <a:rPr lang="nl-BE" sz="1600" dirty="0">
+                <a:sym typeface="Wingdings" panose="05000000000000000000" pitchFamily="2" charset="2"/>
+              </a:rPr>
+              <a:t> </a:t>
+            </a:r>
+            <a:endParaRPr lang="nl-BE" sz="1600" dirty="0"/>
+          </a:p>
+        </p:txBody>
+      </p:sp>
+      <p:sp>
+        <p:nvSpPr>
+          <p:cNvPr id="46" name="TextBox 38">
+            <a:extLst>
+              <a:ext uri="{FF2B5EF4-FFF2-40B4-BE49-F238E27FC236}">
+                <a16:creationId xmlns:a16="http://schemas.microsoft.com/office/drawing/2014/main" id="{AF33DA72-FAC9-DFD8-DF88-95C3AE1E42E8}"/>
+              </a:ext>
+            </a:extLst>
+          </p:cNvPr>
+          <p:cNvSpPr txBox="1"/>
+          <p:nvPr/>
+        </p:nvSpPr>
+        <p:spPr>
+          <a:xfrm>
+            <a:off x="8504226" y="1114046"/>
+            <a:ext cx="829074" cy="261610"/>
           </a:xfrm>
           <a:prstGeom prst="rect">
             <a:avLst/>
           </a:prstGeom>
-        </p:spPr>
-        <p:txBody>
-          <a:bodyPr wrap="none">
+          <a:noFill/>
+        </p:spPr>
+        <p:txBody>
+          <a:bodyPr wrap="none" rtlCol="0">
             <a:spAutoFit/>
           </a:bodyPr>
           <a:lstStyle/>
           <a:p>
             <a:pPr algn="ctr"/>
             <a:r>
-              <a:rPr lang="nl-BE" sz="1100" dirty="0"/>
-              <a:t>mean-thresholds.csv</a:t>
-            </a:r>
-          </a:p>
-          <a:p>
-            <a:pPr algn="ctr"/>
-            <a:r>
-              <a:rPr lang="nl-BE" sz="1100" i="1" dirty="0" err="1"/>
-              <a:t>Mean</a:t>
-            </a:r>
-            <a:r>
-              <a:rPr lang="nl-BE" sz="1100" i="1" dirty="0"/>
-              <a:t> </a:t>
-            </a:r>
-            <a:r>
-              <a:rPr lang="nl-BE" sz="1100" i="1" dirty="0" err="1"/>
-              <a:t>thresholds</a:t>
-            </a:r>
-            <a:r>
-              <a:rPr lang="nl-BE" sz="1100" i="1" dirty="0"/>
-              <a:t> </a:t>
-            </a:r>
-            <a:r>
-              <a:rPr lang="nl-BE" sz="1100" i="1" dirty="0" err="1"/>
-              <a:t>for</a:t>
-            </a:r>
-            <a:r>
-              <a:rPr lang="nl-BE" sz="1100" i="1" dirty="0"/>
-              <a:t> </a:t>
-            </a:r>
-            <a:r>
-              <a:rPr lang="nl-BE" sz="1100" i="1" dirty="0" err="1"/>
-              <a:t>each</a:t>
-            </a:r>
-            <a:r>
-              <a:rPr lang="nl-BE" sz="1100" i="1" dirty="0"/>
-              <a:t> </a:t>
-            </a:r>
-            <a:r>
-              <a:rPr lang="nl-BE" sz="1100" i="1" dirty="0" err="1"/>
-              <a:t>region</a:t>
-            </a:r>
-            <a:endParaRPr lang="nl-BE" sz="1100" dirty="0"/>
-          </a:p>
-        </p:txBody>
-      </p:sp>
-      <p:sp>
-        <p:nvSpPr>
-          <p:cNvPr id="106" name="Rectangle 105">
-            <a:extLst>
-              <a:ext uri="{FF2B5EF4-FFF2-40B4-BE49-F238E27FC236}">
-                <a16:creationId xmlns:a16="http://schemas.microsoft.com/office/drawing/2014/main" id="{A429E801-4C0A-4155-A4C1-AF817FF5ABB4}"/>
-              </a:ext>
-            </a:extLst>
-          </p:cNvPr>
-          <p:cNvSpPr/>
-          <p:nvPr/>
-        </p:nvSpPr>
-        <p:spPr>
-          <a:xfrm>
-            <a:off x="8824252" y="4455321"/>
-            <a:ext cx="2392001" cy="430887"/>
-          </a:xfrm>
-          <a:prstGeom prst="rect">
-            <a:avLst/>
-          </a:prstGeom>
-        </p:spPr>
-        <p:txBody>
-          <a:bodyPr wrap="none">
-            <a:spAutoFit/>
-          </a:bodyPr>
-          <a:lstStyle/>
-          <a:p>
-            <a:pPr algn="ctr"/>
-            <a:r>
-              <a:rPr lang="nl-BE" sz="1100" dirty="0"/>
-              <a:t>statistics.csv</a:t>
-            </a:r>
-          </a:p>
-          <a:p>
-            <a:pPr algn="ctr"/>
-            <a:r>
-              <a:rPr lang="nl-BE" sz="1100" i="1" dirty="0" err="1"/>
-              <a:t>All</a:t>
-            </a:r>
-            <a:r>
-              <a:rPr lang="nl-BE" sz="1100" i="1" dirty="0"/>
-              <a:t> </a:t>
-            </a:r>
-            <a:r>
-              <a:rPr lang="nl-BE" sz="1100" i="1" dirty="0" err="1"/>
-              <a:t>statistics</a:t>
-            </a:r>
-            <a:r>
-              <a:rPr lang="nl-BE" sz="1100" i="1" dirty="0"/>
-              <a:t> </a:t>
-            </a:r>
-            <a:r>
-              <a:rPr lang="nl-BE" sz="1100" i="1" dirty="0" err="1"/>
-              <a:t>concerning</a:t>
-            </a:r>
-            <a:r>
-              <a:rPr lang="nl-BE" sz="1100" i="1" dirty="0"/>
-              <a:t> </a:t>
-            </a:r>
-            <a:r>
-              <a:rPr lang="nl-BE" sz="1100" i="1" dirty="0" err="1"/>
-              <a:t>the</a:t>
-            </a:r>
-            <a:r>
-              <a:rPr lang="nl-BE" sz="1100" i="1" dirty="0"/>
-              <a:t> </a:t>
-            </a:r>
-            <a:r>
-              <a:rPr lang="nl-BE" sz="1100" i="1" dirty="0" err="1"/>
-              <a:t>calculation</a:t>
-            </a:r>
-            <a:endParaRPr lang="nl-BE" sz="1100" dirty="0"/>
-          </a:p>
-        </p:txBody>
-      </p:sp>
-      <p:sp>
-        <p:nvSpPr>
-          <p:cNvPr id="107" name="Rectangle 106">
-            <a:extLst>
-              <a:ext uri="{FF2B5EF4-FFF2-40B4-BE49-F238E27FC236}">
-                <a16:creationId xmlns:a16="http://schemas.microsoft.com/office/drawing/2014/main" id="{B73833DE-01DC-4DBC-AC0D-167CC8010FFD}"/>
-              </a:ext>
-            </a:extLst>
-          </p:cNvPr>
-          <p:cNvSpPr/>
-          <p:nvPr/>
-        </p:nvSpPr>
-        <p:spPr>
-          <a:xfrm>
-            <a:off x="9406742" y="5156299"/>
-            <a:ext cx="1418979" cy="430887"/>
-          </a:xfrm>
-          <a:prstGeom prst="rect">
-            <a:avLst/>
-          </a:prstGeom>
-        </p:spPr>
-        <p:txBody>
-          <a:bodyPr wrap="none">
-            <a:spAutoFit/>
-          </a:bodyPr>
-          <a:lstStyle/>
-          <a:p>
-            <a:pPr algn="ctr"/>
-            <a:r>
-              <a:rPr lang="nl-BE" sz="1100" dirty="0"/>
-              <a:t>statistics.png</a:t>
-            </a:r>
-          </a:p>
-          <a:p>
-            <a:pPr algn="ctr"/>
-            <a:r>
-              <a:rPr lang="nl-BE" sz="1100" i="1" dirty="0" err="1"/>
-              <a:t>All</a:t>
-            </a:r>
-            <a:r>
-              <a:rPr lang="nl-BE" sz="1100" i="1" dirty="0"/>
-              <a:t> </a:t>
-            </a:r>
-            <a:r>
-              <a:rPr lang="nl-BE" sz="1100" i="1" dirty="0" err="1"/>
-              <a:t>statistics</a:t>
-            </a:r>
-            <a:r>
-              <a:rPr lang="nl-BE" sz="1100" i="1" dirty="0"/>
-              <a:t> in </a:t>
-            </a:r>
-            <a:r>
-              <a:rPr lang="nl-BE" sz="1100" i="1" dirty="0" err="1"/>
-              <a:t>figures</a:t>
-            </a:r>
-            <a:endParaRPr lang="nl-BE" sz="1100" dirty="0"/>
-          </a:p>
-        </p:txBody>
-      </p:sp>
-      <p:sp>
-        <p:nvSpPr>
-          <p:cNvPr id="108" name="Rectangle 107">
-            <a:extLst>
-              <a:ext uri="{FF2B5EF4-FFF2-40B4-BE49-F238E27FC236}">
-                <a16:creationId xmlns:a16="http://schemas.microsoft.com/office/drawing/2014/main" id="{008A4504-F491-4A37-8A2C-07DEA863EDD7}"/>
-              </a:ext>
-            </a:extLst>
-          </p:cNvPr>
-          <p:cNvSpPr/>
-          <p:nvPr/>
-        </p:nvSpPr>
-        <p:spPr>
-          <a:xfrm>
-            <a:off x="8181534" y="5785529"/>
-            <a:ext cx="3902030" cy="430887"/>
-          </a:xfrm>
-          <a:prstGeom prst="rect">
-            <a:avLst/>
-          </a:prstGeom>
-        </p:spPr>
-        <p:txBody>
-          <a:bodyPr wrap="none">
-            <a:spAutoFit/>
-          </a:bodyPr>
-          <a:lstStyle/>
-          <a:p>
-            <a:pPr algn="ctr"/>
-            <a:r>
-              <a:rPr lang="nl-BE" sz="1100" dirty="0" err="1"/>
-              <a:t>image_spots</a:t>
-            </a:r>
-            <a:endParaRPr lang="nl-BE" sz="1100" dirty="0"/>
-          </a:p>
-          <a:p>
-            <a:pPr algn="ctr"/>
-            <a:r>
-              <a:rPr lang="nl-BE" sz="1100" i="1" dirty="0" err="1"/>
-              <a:t>Overlapped</a:t>
-            </a:r>
-            <a:r>
-              <a:rPr lang="nl-BE" sz="1100" i="1" dirty="0"/>
-              <a:t> </a:t>
-            </a:r>
-            <a:r>
-              <a:rPr lang="nl-BE" sz="1100" i="1" dirty="0" err="1"/>
-              <a:t>regions</a:t>
-            </a:r>
-            <a:r>
-              <a:rPr lang="nl-BE" sz="1100" i="1" dirty="0"/>
-              <a:t> </a:t>
-            </a:r>
-            <a:r>
-              <a:rPr lang="nl-BE" sz="1100" i="1" dirty="0" err="1"/>
-              <a:t>for</a:t>
-            </a:r>
-            <a:r>
-              <a:rPr lang="nl-BE" sz="1100" i="1" dirty="0"/>
-              <a:t> </a:t>
-            </a:r>
-            <a:r>
-              <a:rPr lang="nl-BE" sz="1100" i="1" dirty="0" err="1"/>
-              <a:t>each</a:t>
-            </a:r>
-            <a:r>
-              <a:rPr lang="nl-BE" sz="1100" i="1" dirty="0"/>
-              <a:t> pair of images </a:t>
-            </a:r>
-            <a:r>
-              <a:rPr lang="nl-BE" sz="1100" i="1" dirty="0" err="1"/>
-              <a:t>with</a:t>
-            </a:r>
-            <a:r>
-              <a:rPr lang="nl-BE" sz="1100" i="1" dirty="0"/>
-              <a:t> </a:t>
-            </a:r>
-            <a:r>
-              <a:rPr lang="nl-BE" sz="1100" i="1" dirty="0" err="1"/>
-              <a:t>mean</a:t>
-            </a:r>
-            <a:r>
-              <a:rPr lang="nl-BE" sz="1100" i="1" dirty="0"/>
-              <a:t> </a:t>
-            </a:r>
-            <a:r>
-              <a:rPr lang="nl-BE" sz="1100" i="1" dirty="0" err="1"/>
-              <a:t>thresholds</a:t>
-            </a:r>
-            <a:endParaRPr lang="nl-BE" sz="1100" dirty="0"/>
+              <a:rPr lang="nl-BE" sz="1100" dirty="0">
+                <a:solidFill>
+                  <a:schemeClr val="bg1"/>
+                </a:solidFill>
+              </a:rPr>
+              <a:t>overlap.csv</a:t>
+            </a:r>
           </a:p>
         </p:txBody>
       </p:sp>
       <p:pic>
         <p:nvPicPr>
-          <p:cNvPr id="109" name="Picture 108">
-            <a:extLst>
-              <a:ext uri="{FF2B5EF4-FFF2-40B4-BE49-F238E27FC236}">
-                <a16:creationId xmlns:a16="http://schemas.microsoft.com/office/drawing/2014/main" id="{2056B11B-6B45-496A-9D65-E4F1BB5DB290}"/>
+          <p:cNvPr id="48" name="Picture 29">
+            <a:extLst>
+              <a:ext uri="{FF2B5EF4-FFF2-40B4-BE49-F238E27FC236}">
+                <a16:creationId xmlns:a16="http://schemas.microsoft.com/office/drawing/2014/main" id="{2074E591-3242-B29F-E912-F6EC6C1ACECA}"/>
               </a:ext>
             </a:extLst>
           </p:cNvPr>
@@ -12429,69 +12514,195 @@
           <p:nvPr/>
         </p:nvPicPr>
         <p:blipFill>
-          <a:blip r:embed="rId6"/>
+          <a:blip r:embed="rId3"/>
           <a:stretch>
             <a:fillRect/>
           </a:stretch>
         </p:blipFill>
         <p:spPr>
           <a:xfrm>
-            <a:off x="174352" y="536129"/>
-            <a:ext cx="2184695" cy="846805"/>
+            <a:off x="8656761" y="1389986"/>
+            <a:ext cx="524004" cy="562533"/>
           </a:xfrm>
           <a:prstGeom prst="rect">
             <a:avLst/>
           </a:prstGeom>
         </p:spPr>
       </p:pic>
-      <p:sp>
-        <p:nvSpPr>
-          <p:cNvPr id="6" name="Tekstvak 5">
-            <a:extLst>
-              <a:ext uri="{FF2B5EF4-FFF2-40B4-BE49-F238E27FC236}">
-                <a16:creationId xmlns:a16="http://schemas.microsoft.com/office/drawing/2014/main" id="{150A32B2-BE43-92C3-0D90-C0C7BE9F92F4}"/>
-              </a:ext>
-            </a:extLst>
-          </p:cNvPr>
-          <p:cNvSpPr txBox="1"/>
-          <p:nvPr/>
-        </p:nvSpPr>
-        <p:spPr>
-          <a:xfrm>
-            <a:off x="337335" y="66280"/>
-            <a:ext cx="1915396" cy="646331"/>
-          </a:xfrm>
-          <a:prstGeom prst="rect">
-            <a:avLst/>
-          </a:prstGeom>
-          <a:noFill/>
-        </p:spPr>
-        <p:txBody>
-          <a:bodyPr wrap="none" rtlCol="0">
-            <a:spAutoFit/>
-          </a:bodyPr>
-          <a:lstStyle/>
-          <a:p>
-            <a:pPr algn="ctr"/>
-            <a:r>
-              <a:rPr lang="en-US" b="1" dirty="0"/>
-              <a:t>Simplified </a:t>
-            </a:r>
-          </a:p>
-          <a:p>
-            <a:pPr algn="ctr"/>
-            <a:r>
-              <a:rPr lang="en-US" b="1" dirty="0"/>
-              <a:t>surrogate pipeline</a:t>
-            </a:r>
-            <a:endParaRPr lang="nl-NL" b="1" dirty="0"/>
-          </a:p>
-        </p:txBody>
-      </p:sp>
     </p:spTree>
     <p:extLst>
       <p:ext uri="{BB962C8B-B14F-4D97-AF65-F5344CB8AC3E}">
         <p14:creationId xmlns:p14="http://schemas.microsoft.com/office/powerpoint/2010/main" val="3663025725"/>
+      </p:ext>
+    </p:extLst>
+  </p:cSld>
+  <p:clrMapOvr>
+    <a:masterClrMapping/>
+  </p:clrMapOvr>
+</p:sld>
+</file>
+
+<file path=ppt/slides/slide5.xml><?xml version="1.0" encoding="utf-8"?>
+<p:sld xmlns:a="http://schemas.openxmlformats.org/drawingml/2006/main" xmlns:r="http://schemas.openxmlformats.org/officeDocument/2006/relationships" xmlns:p="http://schemas.openxmlformats.org/presentationml/2006/main">
+  <p:cSld>
+    <p:spTree>
+      <p:nvGrpSpPr>
+        <p:cNvPr id="1" name=""/>
+        <p:cNvGrpSpPr/>
+        <p:nvPr/>
+      </p:nvGrpSpPr>
+      <p:grpSpPr>
+        <a:xfrm>
+          <a:off x="0" y="0"/>
+          <a:ext cx="0" cy="0"/>
+          <a:chOff x="0" y="0"/>
+          <a:chExt cx="0" cy="0"/>
+        </a:xfrm>
+      </p:grpSpPr>
+      <p:sp>
+        <p:nvSpPr>
+          <p:cNvPr id="2" name="Tekstvak 1">
+            <a:extLst>
+              <a:ext uri="{FF2B5EF4-FFF2-40B4-BE49-F238E27FC236}">
+                <a16:creationId xmlns:a16="http://schemas.microsoft.com/office/drawing/2014/main" id="{9B03F2DF-DABD-C7EA-F2CB-4522E3430A90}"/>
+              </a:ext>
+            </a:extLst>
+          </p:cNvPr>
+          <p:cNvSpPr txBox="1"/>
+          <p:nvPr/>
+        </p:nvSpPr>
+        <p:spPr>
+          <a:xfrm>
+            <a:off x="337335" y="46615"/>
+            <a:ext cx="1915396" cy="646331"/>
+          </a:xfrm>
+          <a:prstGeom prst="rect">
+            <a:avLst/>
+          </a:prstGeom>
+          <a:noFill/>
+        </p:spPr>
+        <p:txBody>
+          <a:bodyPr wrap="none" rtlCol="0">
+            <a:spAutoFit/>
+          </a:bodyPr>
+          <a:lstStyle/>
+          <a:p>
+            <a:pPr algn="ctr"/>
+            <a:r>
+              <a:rPr lang="en-US" b="1" dirty="0"/>
+              <a:t>Simplified </a:t>
+            </a:r>
+          </a:p>
+          <a:p>
+            <a:pPr algn="ctr"/>
+            <a:r>
+              <a:rPr lang="en-US" b="1" dirty="0"/>
+              <a:t>surrogate pipeline</a:t>
+            </a:r>
+            <a:endParaRPr lang="nl-NL" b="1" dirty="0"/>
+          </a:p>
+        </p:txBody>
+      </p:sp>
+      <p:pic>
+        <p:nvPicPr>
+          <p:cNvPr id="4" name="Afbeelding 3" descr="Afbeelding met tekst, schermopname, diagram, lijn&#10;&#10;Automatisch gegenereerde beschrijving">
+            <a:extLst>
+              <a:ext uri="{FF2B5EF4-FFF2-40B4-BE49-F238E27FC236}">
+                <a16:creationId xmlns:a16="http://schemas.microsoft.com/office/drawing/2014/main" id="{DFF26D52-2F21-86C0-1B99-C47FB400AE42}"/>
+              </a:ext>
+            </a:extLst>
+          </p:cNvPr>
+          <p:cNvPicPr>
+            <a:picLocks noChangeAspect="1"/>
+          </p:cNvPicPr>
+          <p:nvPr/>
+        </p:nvPicPr>
+        <p:blipFill>
+          <a:blip r:embed="rId2">
+            <a:extLst>
+              <a:ext uri="{28A0092B-C50C-407E-A947-70E740481C1C}">
+                <a14:useLocalDpi xmlns:a14="http://schemas.microsoft.com/office/drawing/2010/main" val="0"/>
+              </a:ext>
+            </a:extLst>
+          </a:blip>
+          <a:stretch>
+            <a:fillRect/>
+          </a:stretch>
+        </p:blipFill>
+        <p:spPr>
+          <a:xfrm>
+            <a:off x="5765630" y="821480"/>
+            <a:ext cx="5852172" cy="4389129"/>
+          </a:xfrm>
+          <a:prstGeom prst="rect">
+            <a:avLst/>
+          </a:prstGeom>
+        </p:spPr>
+      </p:pic>
+      <p:pic>
+        <p:nvPicPr>
+          <p:cNvPr id="6" name="Afbeelding 5">
+            <a:extLst>
+              <a:ext uri="{FF2B5EF4-FFF2-40B4-BE49-F238E27FC236}">
+                <a16:creationId xmlns:a16="http://schemas.microsoft.com/office/drawing/2014/main" id="{85B865E3-7F41-BE2D-4D9B-53D53E9754A6}"/>
+              </a:ext>
+            </a:extLst>
+          </p:cNvPr>
+          <p:cNvPicPr>
+            <a:picLocks noChangeAspect="1"/>
+          </p:cNvPicPr>
+          <p:nvPr/>
+        </p:nvPicPr>
+        <p:blipFill>
+          <a:blip r:embed="rId3"/>
+          <a:stretch>
+            <a:fillRect/>
+          </a:stretch>
+        </p:blipFill>
+        <p:spPr>
+          <a:xfrm>
+            <a:off x="418231" y="2125476"/>
+            <a:ext cx="4130615" cy="2885281"/>
+          </a:xfrm>
+          <a:prstGeom prst="rect">
+            <a:avLst/>
+          </a:prstGeom>
+        </p:spPr>
+      </p:pic>
+      <p:pic>
+        <p:nvPicPr>
+          <p:cNvPr id="10" name="Afbeelding 9">
+            <a:extLst>
+              <a:ext uri="{FF2B5EF4-FFF2-40B4-BE49-F238E27FC236}">
+                <a16:creationId xmlns:a16="http://schemas.microsoft.com/office/drawing/2014/main" id="{D444019B-BBD1-530D-4493-98BFF6F9DD2B}"/>
+              </a:ext>
+            </a:extLst>
+          </p:cNvPr>
+          <p:cNvPicPr>
+            <a:picLocks noChangeAspect="1"/>
+          </p:cNvPicPr>
+          <p:nvPr/>
+        </p:nvPicPr>
+        <p:blipFill>
+          <a:blip r:embed="rId4"/>
+          <a:stretch>
+            <a:fillRect/>
+          </a:stretch>
+        </p:blipFill>
+        <p:spPr>
+          <a:xfrm>
+            <a:off x="418231" y="1283109"/>
+            <a:ext cx="2522040" cy="252204"/>
+          </a:xfrm>
+          <a:prstGeom prst="rect">
+            <a:avLst/>
+          </a:prstGeom>
+        </p:spPr>
+      </p:pic>
+    </p:spTree>
+    <p:extLst>
+      <p:ext uri="{BB962C8B-B14F-4D97-AF65-F5344CB8AC3E}">
+        <p14:creationId xmlns:p14="http://schemas.microsoft.com/office/powerpoint/2010/main" val="3857968954"/>
       </p:ext>
     </p:extLst>
   </p:cSld>

</xml_diff>

<commit_message>
cleaned-up the work space and did some small adjustments
</commit_message>
<xml_diff>
--- a/image-analysis/synapse-counting/project-overview.pptx
+++ b/image-analysis/synapse-counting/project-overview.pptx
@@ -265,7 +265,7 @@
           <a:p>
             <a:fld id="{B741DFA4-C744-40DA-B848-2124ADC83FCF}" type="datetimeFigureOut">
               <a:rPr lang="nl-BE" smtClean="0"/>
-              <a:t>25/08/2023</a:t>
+              <a:t>28/08/2023</a:t>
             </a:fld>
             <a:endParaRPr lang="nl-BE"/>
           </a:p>
@@ -465,7 +465,7 @@
           <a:p>
             <a:fld id="{B741DFA4-C744-40DA-B848-2124ADC83FCF}" type="datetimeFigureOut">
               <a:rPr lang="nl-BE" smtClean="0"/>
-              <a:t>25/08/2023</a:t>
+              <a:t>28/08/2023</a:t>
             </a:fld>
             <a:endParaRPr lang="nl-BE"/>
           </a:p>
@@ -675,7 +675,7 @@
           <a:p>
             <a:fld id="{B741DFA4-C744-40DA-B848-2124ADC83FCF}" type="datetimeFigureOut">
               <a:rPr lang="nl-BE" smtClean="0"/>
-              <a:t>25/08/2023</a:t>
+              <a:t>28/08/2023</a:t>
             </a:fld>
             <a:endParaRPr lang="nl-BE"/>
           </a:p>
@@ -875,7 +875,7 @@
           <a:p>
             <a:fld id="{B741DFA4-C744-40DA-B848-2124ADC83FCF}" type="datetimeFigureOut">
               <a:rPr lang="nl-BE" smtClean="0"/>
-              <a:t>25/08/2023</a:t>
+              <a:t>28/08/2023</a:t>
             </a:fld>
             <a:endParaRPr lang="nl-BE"/>
           </a:p>
@@ -1151,7 +1151,7 @@
           <a:p>
             <a:fld id="{B741DFA4-C744-40DA-B848-2124ADC83FCF}" type="datetimeFigureOut">
               <a:rPr lang="nl-BE" smtClean="0"/>
-              <a:t>25/08/2023</a:t>
+              <a:t>28/08/2023</a:t>
             </a:fld>
             <a:endParaRPr lang="nl-BE"/>
           </a:p>
@@ -1419,7 +1419,7 @@
           <a:p>
             <a:fld id="{B741DFA4-C744-40DA-B848-2124ADC83FCF}" type="datetimeFigureOut">
               <a:rPr lang="nl-BE" smtClean="0"/>
-              <a:t>25/08/2023</a:t>
+              <a:t>28/08/2023</a:t>
             </a:fld>
             <a:endParaRPr lang="nl-BE"/>
           </a:p>
@@ -1834,7 +1834,7 @@
           <a:p>
             <a:fld id="{B741DFA4-C744-40DA-B848-2124ADC83FCF}" type="datetimeFigureOut">
               <a:rPr lang="nl-BE" smtClean="0"/>
-              <a:t>25/08/2023</a:t>
+              <a:t>28/08/2023</a:t>
             </a:fld>
             <a:endParaRPr lang="nl-BE"/>
           </a:p>
@@ -1976,7 +1976,7 @@
           <a:p>
             <a:fld id="{B741DFA4-C744-40DA-B848-2124ADC83FCF}" type="datetimeFigureOut">
               <a:rPr lang="nl-BE" smtClean="0"/>
-              <a:t>25/08/2023</a:t>
+              <a:t>28/08/2023</a:t>
             </a:fld>
             <a:endParaRPr lang="nl-BE"/>
           </a:p>
@@ -2089,7 +2089,7 @@
           <a:p>
             <a:fld id="{B741DFA4-C744-40DA-B848-2124ADC83FCF}" type="datetimeFigureOut">
               <a:rPr lang="nl-BE" smtClean="0"/>
-              <a:t>25/08/2023</a:t>
+              <a:t>28/08/2023</a:t>
             </a:fld>
             <a:endParaRPr lang="nl-BE"/>
           </a:p>
@@ -2402,7 +2402,7 @@
           <a:p>
             <a:fld id="{B741DFA4-C744-40DA-B848-2124ADC83FCF}" type="datetimeFigureOut">
               <a:rPr lang="nl-BE" smtClean="0"/>
-              <a:t>25/08/2023</a:t>
+              <a:t>28/08/2023</a:t>
             </a:fld>
             <a:endParaRPr lang="nl-BE"/>
           </a:p>
@@ -2691,7 +2691,7 @@
           <a:p>
             <a:fld id="{B741DFA4-C744-40DA-B848-2124ADC83FCF}" type="datetimeFigureOut">
               <a:rPr lang="nl-BE" smtClean="0"/>
-              <a:t>25/08/2023</a:t>
+              <a:t>28/08/2023</a:t>
             </a:fld>
             <a:endParaRPr lang="nl-BE"/>
           </a:p>
@@ -2934,7 +2934,7 @@
           <a:p>
             <a:fld id="{B741DFA4-C744-40DA-B848-2124ADC83FCF}" type="datetimeFigureOut">
               <a:rPr lang="nl-BE" smtClean="0"/>
-              <a:t>25/08/2023</a:t>
+              <a:t>28/08/2023</a:t>
             </a:fld>
             <a:endParaRPr lang="nl-BE"/>
           </a:p>
@@ -10055,7 +10055,7 @@
         <p:spPr>
           <a:xfrm>
             <a:off x="2572787" y="331531"/>
-            <a:ext cx="8067740" cy="3381375"/>
+            <a:ext cx="8067740" cy="3434019"/>
           </a:xfrm>
           <a:prstGeom prst="roundRect">
             <a:avLst/>

</xml_diff>